<commit_message>
docs: replace image screenshots with high-quality vector content cards, visual indicators, and vibrant clinical colors
</commit_message>
<xml_diff>
--- a/presentation/Medical_Diagnosis_System_Presentation.pptx
+++ b/presentation/Medical_Diagnosis_System_Presentation.pptx
@@ -11,6 +11,10 @@
     <p:sldId id="259" r:id="rId10"/>
     <p:sldId id="260" r:id="rId11"/>
     <p:sldId id="261" r:id="rId12"/>
+    <p:sldId id="262" r:id="rId13"/>
+    <p:sldId id="263" r:id="rId14"/>
+    <p:sldId id="264" r:id="rId15"/>
+    <p:sldId id="265" r:id="rId16"/>
   </p:sldIdLst>
   <p:sldSz cx="12191695" cy="6858000" type="screen4x3"/>
   <p:notesSz cx="6858000" cy="9144000"/>
@@ -3159,7 +3163,7 @@
           <a:lstStyle/>
           <a:p>
             <a:pPr>
-              <a:defRPr sz="3800" b="1">
+              <a:defRPr sz="4000" b="1">
                 <a:solidFill>
                   <a:srgbClr val="F1F5F9"/>
                 </a:solidFill>
@@ -3205,7 +3209,7 @@
               </a:defRPr>
             </a:pPr>
             <a:r>
-              <a:t>Relational logic reasoning, targeted questioning, and lab confirmation</a:t>
+              <a:t>An explainable relational logic expert system for targeted triage, 3-disease questioning, and lab confirmation</a:t>
             </a:r>
           </a:p>
         </p:txBody>
@@ -3235,12 +3239,449 @@
             <a:pPr>
               <a:defRPr sz="1300" b="1">
                 <a:solidFill>
+                  <a:srgbClr val="10B981"/>
+                </a:solidFill>
+              </a:defRPr>
+            </a:pPr>
+            <a:r>
+              <a:t>Python Kanren Core   |   REST API Architecture   |   Clinician Portal UI</a:t>
+            </a:r>
+          </a:p>
+        </p:txBody>
+      </p:sp>
+    </p:spTree>
+  </p:cSld>
+  <p:clrMapOvr>
+    <a:masterClrMapping/>
+  </p:clrMapOvr>
+</p:sld>
+</file>
+
+<file path=ppt/slides/slide10.xml><?xml version="1.0" encoding="utf-8"?>
+<p:sld xmlns:a="http://schemas.openxmlformats.org/drawingml/2006/main" xmlns:p="http://schemas.openxmlformats.org/presentationml/2006/main" xmlns:r="http://schemas.openxmlformats.org/officeDocument/2006/relationships">
+  <p:cSld>
+    <p:bg>
+      <p:bgPr>
+        <a:solidFill>
+          <a:srgbClr val="0F172A"/>
+        </a:solidFill>
+        <a:effectLst/>
+      </p:bgPr>
+    </p:bg>
+    <p:spTree>
+      <p:nvGrpSpPr>
+        <p:cNvPr id="1" name=""/>
+        <p:cNvGrpSpPr/>
+        <p:nvPr/>
+      </p:nvGrpSpPr>
+      <p:grpSpPr/>
+      <p:sp>
+        <p:nvSpPr>
+          <p:cNvPr id="2" name="TextBox 1"/>
+          <p:cNvSpPr txBox="1"/>
+          <p:nvPr/>
+        </p:nvSpPr>
+        <p:spPr>
+          <a:xfrm>
+            <a:off x="731520" y="1097280"/>
+            <a:ext cx="10698480" cy="548640"/>
+          </a:xfrm>
+          <a:prstGeom prst="rect">
+            <a:avLst/>
+          </a:prstGeom>
+          <a:noFill/>
+        </p:spPr>
+        <p:txBody>
+          <a:bodyPr wrap="none">
+            <a:spAutoFit/>
+          </a:bodyPr>
+          <a:lstStyle/>
+          <a:p>
+            <a:pPr>
+              <a:defRPr sz="1400" b="1">
+                <a:solidFill>
                   <a:srgbClr val="0EA5E9"/>
                 </a:solidFill>
               </a:defRPr>
             </a:pPr>
             <a:r>
-              <a:t>Student Project Presentation  |  Python Kanren, REST API, Web Workstation</a:t>
+              <a:t>VERIFICATION &amp; PROJECT CONCLUSION</a:t>
+            </a:r>
+          </a:p>
+        </p:txBody>
+      </p:sp>
+      <p:sp>
+        <p:nvSpPr>
+          <p:cNvPr id="3" name="Rounded Rectangle 2"/>
+          <p:cNvSpPr/>
+          <p:nvPr/>
+        </p:nvSpPr>
+        <p:spPr>
+          <a:xfrm>
+            <a:off x="731520" y="1828800"/>
+            <a:ext cx="5120640" cy="4389120"/>
+          </a:xfrm>
+          <a:prstGeom prst="roundRect">
+            <a:avLst/>
+          </a:prstGeom>
+          <a:solidFill>
+            <a:srgbClr val="0F172A"/>
+          </a:solidFill>
+          <a:ln w="19050">
+            <a:solidFill>
+              <a:srgbClr val="E2E8F0"/>
+            </a:solidFill>
+          </a:ln>
+        </p:spPr>
+        <p:style>
+          <a:lnRef idx="1">
+            <a:schemeClr val="accent1"/>
+          </a:lnRef>
+          <a:fillRef idx="3">
+            <a:schemeClr val="accent1"/>
+          </a:fillRef>
+          <a:effectRef idx="2">
+            <a:schemeClr val="accent1"/>
+          </a:effectRef>
+          <a:fontRef idx="minor">
+            <a:schemeClr val="lt1"/>
+          </a:fontRef>
+        </p:style>
+        <p:txBody>
+          <a:bodyPr rtlCol="0" anchor="ctr"/>
+          <a:lstStyle/>
+          <a:p>
+            <a:pPr algn="ctr"/>
+          </a:p>
+        </p:txBody>
+      </p:sp>
+      <p:sp>
+        <p:nvSpPr>
+          <p:cNvPr id="4" name="TextBox 3"/>
+          <p:cNvSpPr txBox="1"/>
+          <p:nvPr/>
+        </p:nvSpPr>
+        <p:spPr>
+          <a:xfrm>
+            <a:off x="914400" y="2011680"/>
+            <a:ext cx="4754880" cy="4023360"/>
+          </a:xfrm>
+          <a:prstGeom prst="rect">
+            <a:avLst/>
+          </a:prstGeom>
+          <a:noFill/>
+        </p:spPr>
+        <p:txBody>
+          <a:bodyPr wrap="square">
+            <a:spAutoFit/>
+          </a:bodyPr>
+          <a:lstStyle/>
+          <a:p>
+            <a:pPr>
+              <a:spcAft>
+                <a:spcPts val="1000"/>
+              </a:spcAft>
+              <a:defRPr sz="1600" b="1">
+                <a:solidFill>
+                  <a:srgbClr val="10B981"/>
+                </a:solidFill>
+                <a:latin typeface="Arial"/>
+              </a:defRPr>
+            </a:pPr>
+            <a:r>
+              <a:t>Verification &amp; Quality Metrics</a:t>
+            </a:r>
+          </a:p>
+          <a:p>
+            <a:pPr>
+              <a:spcAft>
+                <a:spcPts val="600"/>
+              </a:spcAft>
+              <a:defRPr>
+                <a:latin typeface="Arial"/>
+              </a:defRPr>
+            </a:pPr>
+            <a:r>
+              <a:rPr b="1" sz="1200">
+                <a:solidFill>
+                  <a:srgbClr val="0F172A"/>
+                </a:solidFill>
+              </a:rPr>
+              <a:t>• 9/9 Unit Tests Passed: </a:t>
+            </a:r>
+            <a:r>
+              <a:rPr b="0" sz="1200">
+                <a:solidFill>
+                  <a:srgbClr val="475569"/>
+                </a:solidFill>
+              </a:rPr>
+              <a:t>100% pass rate in tests/test_kanren_engine.py.</a:t>
+            </a:r>
+          </a:p>
+          <a:p>
+            <a:pPr>
+              <a:spcAft>
+                <a:spcPts val="600"/>
+              </a:spcAft>
+              <a:defRPr>
+                <a:latin typeface="Arial"/>
+              </a:defRPr>
+            </a:pPr>
+            <a:r>
+              <a:rPr b="1" sz="1200">
+                <a:solidFill>
+                  <a:srgbClr val="0F172A"/>
+                </a:solidFill>
+              </a:rPr>
+              <a:t>• 0 Compiler Errors: </a:t>
+            </a:r>
+            <a:r>
+              <a:rPr b="0" sz="1200">
+                <a:solidFill>
+                  <a:srgbClr val="475569"/>
+                </a:solidFill>
+              </a:rPr>
+              <a:t>Validated JavaScript client code with Node.js compiler.</a:t>
+            </a:r>
+          </a:p>
+          <a:p>
+            <a:pPr>
+              <a:spcAft>
+                <a:spcPts val="600"/>
+              </a:spcAft>
+              <a:defRPr>
+                <a:latin typeface="Arial"/>
+              </a:defRPr>
+            </a:pPr>
+            <a:r>
+              <a:rPr b="1" sz="1200">
+                <a:solidFill>
+                  <a:srgbClr val="0F172A"/>
+                </a:solidFill>
+              </a:rPr>
+              <a:t>• Authentication Verified: </a:t>
+            </a:r>
+            <a:r>
+              <a:rPr b="0" sz="1200">
+                <a:solidFill>
+                  <a:srgbClr val="475569"/>
+                </a:solidFill>
+              </a:rPr>
+              <a:t>Verified local storage persistence and password validation.</a:t>
+            </a:r>
+          </a:p>
+          <a:p>
+            <a:pPr>
+              <a:spcAft>
+                <a:spcPts val="600"/>
+              </a:spcAft>
+              <a:defRPr>
+                <a:latin typeface="Arial"/>
+              </a:defRPr>
+            </a:pPr>
+            <a:r>
+              <a:rPr b="1" sz="1200">
+                <a:solidFill>
+                  <a:srgbClr val="0F172A"/>
+                </a:solidFill>
+              </a:rPr>
+              <a:t>• Question Sequence Verified: </a:t>
+            </a:r>
+            <a:r>
+              <a:rPr b="0" sz="1200">
+                <a:solidFill>
+                  <a:srgbClr val="475569"/>
+                </a:solidFill>
+              </a:rPr>
+              <a:t>Verified 3-disease sequential questioning and pagination.</a:t>
+            </a:r>
+          </a:p>
+        </p:txBody>
+      </p:sp>
+      <p:sp>
+        <p:nvSpPr>
+          <p:cNvPr id="5" name="Rounded Rectangle 4"/>
+          <p:cNvSpPr/>
+          <p:nvPr/>
+        </p:nvSpPr>
+        <p:spPr>
+          <a:xfrm>
+            <a:off x="6217920" y="1828800"/>
+            <a:ext cx="5212080" cy="4389120"/>
+          </a:xfrm>
+          <a:prstGeom prst="roundRect">
+            <a:avLst/>
+          </a:prstGeom>
+          <a:solidFill>
+            <a:srgbClr val="0F172A"/>
+          </a:solidFill>
+          <a:ln w="19050">
+            <a:solidFill>
+              <a:srgbClr val="E2E8F0"/>
+            </a:solidFill>
+          </a:ln>
+        </p:spPr>
+        <p:style>
+          <a:lnRef idx="1">
+            <a:schemeClr val="accent1"/>
+          </a:lnRef>
+          <a:fillRef idx="3">
+            <a:schemeClr val="accent1"/>
+          </a:fillRef>
+          <a:effectRef idx="2">
+            <a:schemeClr val="accent1"/>
+          </a:effectRef>
+          <a:fontRef idx="minor">
+            <a:schemeClr val="lt1"/>
+          </a:fontRef>
+        </p:style>
+        <p:txBody>
+          <a:bodyPr rtlCol="0" anchor="ctr"/>
+          <a:lstStyle/>
+          <a:p>
+            <a:pPr algn="ctr"/>
+          </a:p>
+        </p:txBody>
+      </p:sp>
+      <p:sp>
+        <p:nvSpPr>
+          <p:cNvPr id="6" name="TextBox 5"/>
+          <p:cNvSpPr txBox="1"/>
+          <p:nvPr/>
+        </p:nvSpPr>
+        <p:spPr>
+          <a:xfrm>
+            <a:off x="6400800" y="2011680"/>
+            <a:ext cx="4846320" cy="4023360"/>
+          </a:xfrm>
+          <a:prstGeom prst="rect">
+            <a:avLst/>
+          </a:prstGeom>
+          <a:noFill/>
+        </p:spPr>
+        <p:txBody>
+          <a:bodyPr wrap="square">
+            <a:spAutoFit/>
+          </a:bodyPr>
+          <a:lstStyle/>
+          <a:p>
+            <a:pPr>
+              <a:spcAft>
+                <a:spcPts val="1000"/>
+              </a:spcAft>
+              <a:defRPr sz="1600" b="1">
+                <a:solidFill>
+                  <a:srgbClr val="0EA5E9"/>
+                </a:solidFill>
+                <a:latin typeface="Arial"/>
+              </a:defRPr>
+            </a:pPr>
+            <a:r>
+              <a:t>Key Project Deliverables</a:t>
+            </a:r>
+          </a:p>
+          <a:p>
+            <a:pPr>
+              <a:spcAft>
+                <a:spcPts val="600"/>
+              </a:spcAft>
+              <a:defRPr>
+                <a:latin typeface="Arial"/>
+              </a:defRPr>
+            </a:pPr>
+            <a:r>
+              <a:rPr b="1" sz="1200">
+                <a:solidFill>
+                  <a:srgbClr val="0F172A"/>
+                </a:solidFill>
+              </a:rPr>
+              <a:t>• Relational Knowledge Engine: </a:t>
+            </a:r>
+            <a:r>
+              <a:rPr b="0" sz="1200">
+                <a:solidFill>
+                  <a:srgbClr val="475569"/>
+                </a:solidFill>
+              </a:rPr>
+              <a:t>Python Kanren declarative rule evaluator.</a:t>
+            </a:r>
+          </a:p>
+          <a:p>
+            <a:pPr>
+              <a:spcAft>
+                <a:spcPts val="600"/>
+              </a:spcAft>
+              <a:defRPr>
+                <a:latin typeface="Arial"/>
+              </a:defRPr>
+            </a:pPr>
+            <a:r>
+              <a:rPr b="1" sz="1200">
+                <a:solidFill>
+                  <a:srgbClr val="0F172A"/>
+                </a:solidFill>
+              </a:rPr>
+              <a:t>• Clinician Portal Workstation: </a:t>
+            </a:r>
+            <a:r>
+              <a:rPr b="0" sz="1200">
+                <a:solidFill>
+                  <a:srgbClr val="475569"/>
+                </a:solidFill>
+              </a:rPr>
+              <a:t>Light-themed medical portal with collapsible sidebar.</a:t>
+            </a:r>
+          </a:p>
+          <a:p>
+            <a:pPr>
+              <a:spcAft>
+                <a:spcPts val="600"/>
+              </a:spcAft>
+              <a:defRPr>
+                <a:latin typeface="Arial"/>
+              </a:defRPr>
+            </a:pPr>
+            <a:r>
+              <a:rPr b="1" sz="1200">
+                <a:solidFill>
+                  <a:srgbClr val="0F172A"/>
+                </a:solidFill>
+              </a:rPr>
+              <a:t>• Sequential Triage Algorithm: </a:t>
+            </a:r>
+            <a:r>
+              <a:rPr b="0" sz="1200">
+                <a:solidFill>
+                  <a:srgbClr val="475569"/>
+                </a:solidFill>
+              </a:rPr>
+              <a:t>Targeted questioning from least-likely to most-likely candidate.</a:t>
+            </a:r>
+          </a:p>
+          <a:p>
+            <a:pPr>
+              <a:spcAft>
+                <a:spcPts val="600"/>
+              </a:spcAft>
+              <a:defRPr>
+                <a:latin typeface="Arial"/>
+              </a:defRPr>
+            </a:pPr>
+            <a:r>
+              <a:rPr b="1" sz="1200">
+                <a:solidFill>
+                  <a:srgbClr val="0F172A"/>
+                </a:solidFill>
+              </a:rPr>
+              <a:t>• Definitive Lab Confirmation: </a:t>
+            </a:r>
+            <a:r>
+              <a:rPr b="0" sz="1200">
+                <a:solidFill>
+                  <a:srgbClr val="475569"/>
+                </a:solidFill>
+              </a:rPr>
+              <a:t>Positive/negative lab processing with medication protocols.</a:t>
             </a:r>
           </a:p>
         </p:txBody>
@@ -3302,7 +3743,7 @@
               </a:defRPr>
             </a:pPr>
             <a:r>
-              <a:t>MEDICAL DIAGNOSIS SYSTEM</a:t>
+              <a:t>MEDICAL DIAGNOSIS EXPERT SYSTEM</a:t>
             </a:r>
           </a:p>
         </p:txBody>
@@ -3338,29 +3779,29 @@
               </a:defRPr>
             </a:pPr>
             <a:r>
-              <a:t>Clinician Portal &amp; Account Storage</a:t>
-            </a:r>
-          </a:p>
-        </p:txBody>
-      </p:sp>
-      <p:sp>
-        <p:nvSpPr>
-          <p:cNvPr id="4" name="Rectangle 3"/>
+              <a:t>Problem Statement &amp; Clinical Challenges</a:t>
+            </a:r>
+          </a:p>
+        </p:txBody>
+      </p:sp>
+      <p:sp>
+        <p:nvSpPr>
+          <p:cNvPr id="4" name="Rounded Rectangle 3"/>
           <p:cNvSpPr/>
           <p:nvPr/>
         </p:nvSpPr>
         <p:spPr>
           <a:xfrm>
             <a:off x="731520" y="1463040"/>
-            <a:ext cx="4389120" cy="4846320"/>
-          </a:xfrm>
-          <a:prstGeom prst="rect">
+            <a:ext cx="3291840" cy="4846320"/>
+          </a:xfrm>
+          <a:prstGeom prst="roundRect">
             <a:avLst/>
           </a:prstGeom>
           <a:solidFill>
             <a:srgbClr val="FFFFFF"/>
           </a:solidFill>
-          <a:ln w="12700">
+          <a:ln w="19050">
             <a:solidFill>
               <a:srgbClr val="E2E8F0"/>
             </a:solidFill>
@@ -3397,7 +3838,7 @@
         <p:spPr>
           <a:xfrm>
             <a:off x="914400" y="1645920"/>
-            <a:ext cx="4023360" cy="4480560"/>
+            <a:ext cx="2926080" cy="4480560"/>
           </a:xfrm>
           <a:prstGeom prst="rect">
             <a:avLst/>
@@ -3416,13 +3857,13 @@
               </a:spcAft>
               <a:defRPr sz="1600" b="1">
                 <a:solidFill>
-                  <a:srgbClr val="4F46E5"/>
-                </a:solidFill>
-                <a:latin typeface="Arial"/>
-              </a:defRPr>
-            </a:pPr>
-            <a:r>
-              <a:t>Portal Authentication Features</a:t>
+                  <a:srgbClr val="6366F1"/>
+                </a:solidFill>
+                <a:latin typeface="Arial"/>
+              </a:defRPr>
+            </a:pPr>
+            <a:r>
+              <a:t>High Triage Caseloads</a:t>
             </a:r>
           </a:p>
           <a:p>
@@ -3440,7 +3881,7 @@
                   <a:srgbClr val="0F172A"/>
                 </a:solidFill>
               </a:rPr>
-              <a:t>• Clinician Sign In &amp; Sign Up: </a:t>
+              <a:t>• High Patient Volumes: </a:t>
             </a:r>
             <a:r>
               <a:rPr b="0" sz="1200">
@@ -3448,7 +3889,7 @@
                   <a:srgbClr val="475569"/>
                 </a:solidFill>
               </a:rPr>
-              <a:t>Allows new users to register profiles and existing clinicians to sign in.</a:t>
+              <a:t>Primary healthcare centers evaluate dozens of patients daily.</a:t>
             </a:r>
           </a:p>
           <a:p>
@@ -3466,7 +3907,7 @@
                   <a:srgbClr val="0F172A"/>
                 </a:solidFill>
               </a:rPr>
-              <a:t>• Local Storage Persistence: </a:t>
+              <a:t>• Time Constraints: </a:t>
             </a:r>
             <a:r>
               <a:rPr b="0" sz="1200">
@@ -3474,7 +3915,7 @@
                   <a:srgbClr val="475569"/>
                 </a:solidFill>
               </a:rPr>
-              <a:t>Account details persist in browser localStorage across page reloads.</a:t>
+              <a:t>Clinicians have limited minutes per consultation to take detailed histories.</a:t>
             </a:r>
           </a:p>
           <a:p>
@@ -3492,7 +3933,7 @@
                   <a:srgbClr val="0F172A"/>
                 </a:solidFill>
               </a:rPr>
-              <a:t>• Collapsible Sidebar: </a:t>
+              <a:t>• Cognitive Fatigue: </a:t>
             </a:r>
             <a:r>
               <a:rPr b="0" sz="1200">
@@ -3500,61 +3941,335 @@
                   <a:srgbClr val="475569"/>
                 </a:solidFill>
               </a:rPr>
-              <a:t>Displays active clinician name, email, facility, and role with toggle control.</a:t>
-            </a:r>
-          </a:p>
-          <a:p>
-            <a:pPr>
-              <a:spcAft>
-                <a:spcPts val="600"/>
-              </a:spcAft>
-              <a:defRPr>
-                <a:latin typeface="Arial"/>
-              </a:defRPr>
-            </a:pPr>
-            <a:r>
-              <a:rPr b="1" sz="1200">
-                <a:solidFill>
-                  <a:srgbClr val="0F172A"/>
-                </a:solidFill>
-              </a:rPr>
-              <a:t>• Sign Out Management: </a:t>
-            </a:r>
-            <a:r>
-              <a:rPr b="0" sz="1200">
-                <a:solidFill>
-                  <a:srgbClr val="475569"/>
-                </a:solidFill>
-              </a:rPr>
-              <a:t>Allows clinicians to end session securely.</a:t>
-            </a:r>
-          </a:p>
-        </p:txBody>
-      </p:sp>
-      <p:pic>
-        <p:nvPicPr>
-          <p:cNvPr id="6" name="Picture 5" descr="app_auth_screen_1786061564997.jpg"/>
-          <p:cNvPicPr>
-            <a:picLocks noChangeAspect="1"/>
-          </p:cNvPicPr>
+              <a:t>Heavy caseloads increase fatigue during preliminary screening.</a:t>
+            </a:r>
+          </a:p>
+        </p:txBody>
+      </p:sp>
+      <p:sp>
+        <p:nvSpPr>
+          <p:cNvPr id="6" name="Rounded Rectangle 5"/>
+          <p:cNvSpPr/>
           <p:nvPr/>
-        </p:nvPicPr>
-        <p:blipFill>
-          <a:blip r:embed="rId2"/>
-          <a:stretch>
-            <a:fillRect/>
-          </a:stretch>
-        </p:blipFill>
-        <p:spPr>
-          <a:xfrm>
-            <a:off x="5394960" y="1463040"/>
-            <a:ext cx="6035040" cy="3368394"/>
+        </p:nvSpPr>
+        <p:spPr>
+          <a:xfrm>
+            <a:off x="4389120" y="1463040"/>
+            <a:ext cx="3291840" cy="4846320"/>
+          </a:xfrm>
+          <a:prstGeom prst="roundRect">
+            <a:avLst/>
+          </a:prstGeom>
+          <a:solidFill>
+            <a:srgbClr val="FFFFFF"/>
+          </a:solidFill>
+          <a:ln w="19050">
+            <a:solidFill>
+              <a:srgbClr val="E2E8F0"/>
+            </a:solidFill>
+          </a:ln>
+        </p:spPr>
+        <p:style>
+          <a:lnRef idx="1">
+            <a:schemeClr val="accent1"/>
+          </a:lnRef>
+          <a:fillRef idx="3">
+            <a:schemeClr val="accent1"/>
+          </a:fillRef>
+          <a:effectRef idx="2">
+            <a:schemeClr val="accent1"/>
+          </a:effectRef>
+          <a:fontRef idx="minor">
+            <a:schemeClr val="lt1"/>
+          </a:fontRef>
+        </p:style>
+        <p:txBody>
+          <a:bodyPr rtlCol="0" anchor="ctr"/>
+          <a:lstStyle/>
+          <a:p>
+            <a:pPr algn="ctr"/>
+          </a:p>
+        </p:txBody>
+      </p:sp>
+      <p:sp>
+        <p:nvSpPr>
+          <p:cNvPr id="7" name="TextBox 6"/>
+          <p:cNvSpPr txBox="1"/>
+          <p:nvPr/>
+        </p:nvSpPr>
+        <p:spPr>
+          <a:xfrm>
+            <a:off x="4572000" y="1645920"/>
+            <a:ext cx="2926080" cy="4480560"/>
           </a:xfrm>
           <a:prstGeom prst="rect">
             <a:avLst/>
           </a:prstGeom>
-        </p:spPr>
-      </p:pic>
+          <a:noFill/>
+        </p:spPr>
+        <p:txBody>
+          <a:bodyPr wrap="square">
+            <a:spAutoFit/>
+          </a:bodyPr>
+          <a:lstStyle/>
+          <a:p>
+            <a:pPr>
+              <a:spcAft>
+                <a:spcPts val="1000"/>
+              </a:spcAft>
+              <a:defRPr sz="1600" b="1">
+                <a:solidFill>
+                  <a:srgbClr val="0EA5E9"/>
+                </a:solidFill>
+                <a:latin typeface="Arial"/>
+              </a:defRPr>
+            </a:pPr>
+            <a:r>
+              <a:t>Overlapping Symptoms</a:t>
+            </a:r>
+          </a:p>
+          <a:p>
+            <a:pPr>
+              <a:spcAft>
+                <a:spcPts val="600"/>
+              </a:spcAft>
+              <a:defRPr>
+                <a:latin typeface="Arial"/>
+              </a:defRPr>
+            </a:pPr>
+            <a:r>
+              <a:rPr b="1" sz="1200">
+                <a:solidFill>
+                  <a:srgbClr val="0F172A"/>
+                </a:solidFill>
+              </a:rPr>
+              <a:t>• Non-Specific Features: </a:t>
+            </a:r>
+            <a:r>
+              <a:rPr b="0" sz="1200">
+                <a:solidFill>
+                  <a:srgbClr val="475569"/>
+                </a:solidFill>
+              </a:rPr>
+              <a:t>Fever, headache, chills, and fatigue accompany multiple diseases.</a:t>
+            </a:r>
+          </a:p>
+          <a:p>
+            <a:pPr>
+              <a:spcAft>
+                <a:spcPts val="600"/>
+              </a:spcAft>
+              <a:defRPr>
+                <a:latin typeface="Arial"/>
+              </a:defRPr>
+            </a:pPr>
+            <a:r>
+              <a:rPr b="1" sz="1200">
+                <a:solidFill>
+                  <a:srgbClr val="0F172A"/>
+                </a:solidFill>
+              </a:rPr>
+              <a:t>• Diagnostic Confusion: </a:t>
+            </a:r>
+            <a:r>
+              <a:rPr b="0" sz="1200">
+                <a:solidFill>
+                  <a:srgbClr val="475569"/>
+                </a:solidFill>
+              </a:rPr>
+              <a:t>Malaria, Typhoid, and Dengue share high initial symptom overlap.</a:t>
+            </a:r>
+          </a:p>
+          <a:p>
+            <a:pPr>
+              <a:spcAft>
+                <a:spcPts val="600"/>
+              </a:spcAft>
+              <a:defRPr>
+                <a:latin typeface="Arial"/>
+              </a:defRPr>
+            </a:pPr>
+            <a:r>
+              <a:rPr b="1" sz="1200">
+                <a:solidFill>
+                  <a:srgbClr val="0F172A"/>
+                </a:solidFill>
+              </a:rPr>
+              <a:t>• Unfocused Orders: </a:t>
+            </a:r>
+            <a:r>
+              <a:rPr b="0" sz="1200">
+                <a:solidFill>
+                  <a:srgbClr val="475569"/>
+                </a:solidFill>
+              </a:rPr>
+              <a:t>Lack of structured questioning causes unnecessary laboratory testing.</a:t>
+            </a:r>
+          </a:p>
+        </p:txBody>
+      </p:sp>
+      <p:sp>
+        <p:nvSpPr>
+          <p:cNvPr id="8" name="Rounded Rectangle 7"/>
+          <p:cNvSpPr/>
+          <p:nvPr/>
+        </p:nvSpPr>
+        <p:spPr>
+          <a:xfrm>
+            <a:off x="8046720" y="1463040"/>
+            <a:ext cx="3383280" cy="4846320"/>
+          </a:xfrm>
+          <a:prstGeom prst="roundRect">
+            <a:avLst/>
+          </a:prstGeom>
+          <a:solidFill>
+            <a:srgbClr val="FFFFFF"/>
+          </a:solidFill>
+          <a:ln w="19050">
+            <a:solidFill>
+              <a:srgbClr val="E2E8F0"/>
+            </a:solidFill>
+          </a:ln>
+        </p:spPr>
+        <p:style>
+          <a:lnRef idx="1">
+            <a:schemeClr val="accent1"/>
+          </a:lnRef>
+          <a:fillRef idx="3">
+            <a:schemeClr val="accent1"/>
+          </a:fillRef>
+          <a:effectRef idx="2">
+            <a:schemeClr val="accent1"/>
+          </a:effectRef>
+          <a:fontRef idx="minor">
+            <a:schemeClr val="lt1"/>
+          </a:fontRef>
+        </p:style>
+        <p:txBody>
+          <a:bodyPr rtlCol="0" anchor="ctr"/>
+          <a:lstStyle/>
+          <a:p>
+            <a:pPr algn="ctr"/>
+          </a:p>
+        </p:txBody>
+      </p:sp>
+      <p:sp>
+        <p:nvSpPr>
+          <p:cNvPr id="9" name="TextBox 8"/>
+          <p:cNvSpPr txBox="1"/>
+          <p:nvPr/>
+        </p:nvSpPr>
+        <p:spPr>
+          <a:xfrm>
+            <a:off x="8229600" y="1645920"/>
+            <a:ext cx="3017520" cy="4480560"/>
+          </a:xfrm>
+          <a:prstGeom prst="rect">
+            <a:avLst/>
+          </a:prstGeom>
+          <a:noFill/>
+        </p:spPr>
+        <p:txBody>
+          <a:bodyPr wrap="square">
+            <a:spAutoFit/>
+          </a:bodyPr>
+          <a:lstStyle/>
+          <a:p>
+            <a:pPr>
+              <a:spcAft>
+                <a:spcPts val="1000"/>
+              </a:spcAft>
+              <a:defRPr sz="1600" b="1">
+                <a:solidFill>
+                  <a:srgbClr val="F59E0B"/>
+                </a:solidFill>
+                <a:latin typeface="Arial"/>
+              </a:defRPr>
+            </a:pPr>
+            <a:r>
+              <a:t>Diagnostic Risks</a:t>
+            </a:r>
+          </a:p>
+          <a:p>
+            <a:pPr>
+              <a:spcAft>
+                <a:spcPts val="600"/>
+              </a:spcAft>
+              <a:defRPr>
+                <a:latin typeface="Arial"/>
+              </a:defRPr>
+            </a:pPr>
+            <a:r>
+              <a:rPr b="1" sz="1200">
+                <a:solidFill>
+                  <a:srgbClr val="0F172A"/>
+                </a:solidFill>
+              </a:rPr>
+              <a:t>• Missed Secondary Signs: </a:t>
+            </a:r>
+            <a:r>
+              <a:rPr b="0" sz="1200">
+                <a:solidFill>
+                  <a:srgbClr val="475569"/>
+                </a:solidFill>
+              </a:rPr>
+              <a:t>Minor clinical features like relative bradycardia are often overlooked.</a:t>
+            </a:r>
+          </a:p>
+          <a:p>
+            <a:pPr>
+              <a:spcAft>
+                <a:spcPts val="600"/>
+              </a:spcAft>
+              <a:defRPr>
+                <a:latin typeface="Arial"/>
+              </a:defRPr>
+            </a:pPr>
+            <a:r>
+              <a:rPr b="1" sz="1200">
+                <a:solidFill>
+                  <a:srgbClr val="0F172A"/>
+                </a:solidFill>
+              </a:rPr>
+              <a:t>• Improper Medication: </a:t>
+            </a:r>
+            <a:r>
+              <a:rPr b="0" sz="1200">
+                <a:solidFill>
+                  <a:srgbClr val="475569"/>
+                </a:solidFill>
+              </a:rPr>
+              <a:t>Treating unconfirmed conditions creates medication risks.</a:t>
+            </a:r>
+          </a:p>
+          <a:p>
+            <a:pPr>
+              <a:spcAft>
+                <a:spcPts val="600"/>
+              </a:spcAft>
+              <a:defRPr>
+                <a:latin typeface="Arial"/>
+              </a:defRPr>
+            </a:pPr>
+            <a:r>
+              <a:rPr b="1" sz="1200">
+                <a:solidFill>
+                  <a:srgbClr val="0F172A"/>
+                </a:solidFill>
+              </a:rPr>
+              <a:t>• Need for Automation: </a:t>
+            </a:r>
+            <a:r>
+              <a:rPr b="0" sz="1200">
+                <a:solidFill>
+                  <a:srgbClr val="475569"/>
+                </a:solidFill>
+              </a:rPr>
+              <a:t>A structured rule-based system improves preliminary diagnostic accuracy.</a:t>
+            </a:r>
+          </a:p>
+        </p:txBody>
+      </p:sp>
     </p:spTree>
   </p:cSld>
   <p:clrMapOvr>
@@ -3612,7 +4327,7 @@
               </a:defRPr>
             </a:pPr>
             <a:r>
-              <a:t>MEDICAL DIAGNOSIS SYSTEM</a:t>
+              <a:t>MEDICAL DIAGNOSIS EXPERT SYSTEM</a:t>
             </a:r>
           </a:p>
         </p:txBody>
@@ -3648,29 +4363,29 @@
               </a:defRPr>
             </a:pPr>
             <a:r>
-              <a:t>Phase 1: Symptom Selection &amp; Input Triage</a:t>
-            </a:r>
-          </a:p>
-        </p:txBody>
-      </p:sp>
-      <p:sp>
-        <p:nvSpPr>
-          <p:cNvPr id="4" name="Rectangle 3"/>
+              <a:t>System Objectives &amp; Clinical Impact</a:t>
+            </a:r>
+          </a:p>
+        </p:txBody>
+      </p:sp>
+      <p:sp>
+        <p:nvSpPr>
+          <p:cNvPr id="4" name="Rounded Rectangle 3"/>
           <p:cNvSpPr/>
           <p:nvPr/>
         </p:nvSpPr>
         <p:spPr>
           <a:xfrm>
             <a:off x="731520" y="1463040"/>
-            <a:ext cx="4389120" cy="4846320"/>
-          </a:xfrm>
-          <a:prstGeom prst="rect">
+            <a:ext cx="5120640" cy="4846320"/>
+          </a:xfrm>
+          <a:prstGeom prst="roundRect">
             <a:avLst/>
           </a:prstGeom>
           <a:solidFill>
             <a:srgbClr val="FFFFFF"/>
           </a:solidFill>
-          <a:ln w="12700">
+          <a:ln w="19050">
             <a:solidFill>
               <a:srgbClr val="E2E8F0"/>
             </a:solidFill>
@@ -3707,7 +4422,7 @@
         <p:spPr>
           <a:xfrm>
             <a:off x="914400" y="1645920"/>
-            <a:ext cx="4023360" cy="4480560"/>
+            <a:ext cx="4754880" cy="4480560"/>
           </a:xfrm>
           <a:prstGeom prst="rect">
             <a:avLst/>
@@ -3732,7 +4447,7 @@
               </a:defRPr>
             </a:pPr>
             <a:r>
-              <a:t>Symptom Intake Workflow</a:t>
+              <a:t>Primary System Objectives</a:t>
             </a:r>
           </a:p>
           <a:p>
@@ -3750,7 +4465,7 @@
                   <a:srgbClr val="0F172A"/>
                 </a:solidFill>
               </a:rPr>
-              <a:t>• Systemic &amp; Organ Taxonomy: </a:t>
+              <a:t>• Structured Triage Intake: </a:t>
             </a:r>
             <a:r>
               <a:rPr b="0" sz="1200">
@@ -3758,7 +4473,7 @@
                   <a:srgbClr val="475569"/>
                 </a:solidFill>
               </a:rPr>
-              <a:t>Organizes symptoms into Systemic, Respiratory, Gastrointestinal, Neurological.</a:t>
+              <a:t>Collect presenting patient symptoms across 6 major organ systems.</a:t>
             </a:r>
           </a:p>
           <a:p>
@@ -3776,7 +4491,7 @@
                   <a:srgbClr val="0F172A"/>
                 </a:solidFill>
               </a:rPr>
-              <a:t>• Risk Factor Exposure: </a:t>
+              <a:t>• Relational Rule Inference: </a:t>
             </a:r>
             <a:r>
               <a:rPr b="0" sz="1200">
@@ -3784,7 +4499,7 @@
                   <a:srgbClr val="475569"/>
                 </a:solidFill>
               </a:rPr>
-              <a:t>Tracks vector exposure, travel history, and unboiled water consumption.</a:t>
+              <a:t>Execute declarative medical rules matching symptoms to disease facts.</a:t>
             </a:r>
           </a:p>
           <a:p>
@@ -3802,7 +4517,7 @@
                   <a:srgbClr val="0F172A"/>
                 </a:solidFill>
               </a:rPr>
-              <a:t>• Custom Notes: </a:t>
+              <a:t>• Sequential Questioning: </a:t>
             </a:r>
             <a:r>
               <a:rPr b="0" sz="1200">
@@ -3810,7 +4525,7 @@
                   <a:srgbClr val="475569"/>
                 </a:solidFill>
               </a:rPr>
-              <a:t>Text area for clinician observation notes.</a:t>
+              <a:t>Query top candidate conditions sequentially starting with the least likely candidate.</a:t>
             </a:r>
           </a:p>
           <a:p>
@@ -3828,7 +4543,7 @@
                   <a:srgbClr val="0F172A"/>
                 </a:solidFill>
               </a:rPr>
-              <a:t>• Execution Trigger: </a:t>
+              <a:t>• Lab Confirmation Testing: </a:t>
             </a:r>
             <a:r>
               <a:rPr b="0" sz="1200">
@@ -3836,35 +4551,199 @@
                   <a:srgbClr val="475569"/>
                 </a:solidFill>
               </a:rPr>
-              <a:t>Single click initiates relational inference.</a:t>
-            </a:r>
-          </a:p>
-        </p:txBody>
-      </p:sp>
-      <p:pic>
-        <p:nvPicPr>
-          <p:cNvPr id="6" name="Picture 5" descr="app_symptom_triage_1786061584505.jpg"/>
-          <p:cNvPicPr>
-            <a:picLocks noChangeAspect="1"/>
-          </p:cNvPicPr>
+              <a:t>Evaluate positive and negative lab outcomes to confirm or rule out conditions.</a:t>
+            </a:r>
+          </a:p>
+        </p:txBody>
+      </p:sp>
+      <p:sp>
+        <p:nvSpPr>
+          <p:cNvPr id="6" name="Rounded Rectangle 5"/>
+          <p:cNvSpPr/>
           <p:nvPr/>
-        </p:nvPicPr>
-        <p:blipFill>
-          <a:blip r:embed="rId2"/>
-          <a:stretch>
-            <a:fillRect/>
-          </a:stretch>
-        </p:blipFill>
-        <p:spPr>
-          <a:xfrm>
-            <a:off x="5394960" y="1463040"/>
-            <a:ext cx="6035040" cy="3368394"/>
+        </p:nvSpPr>
+        <p:spPr>
+          <a:xfrm>
+            <a:off x="6217920" y="1463040"/>
+            <a:ext cx="5212080" cy="4846320"/>
+          </a:xfrm>
+          <a:prstGeom prst="roundRect">
+            <a:avLst/>
+          </a:prstGeom>
+          <a:solidFill>
+            <a:srgbClr val="FFFFFF"/>
+          </a:solidFill>
+          <a:ln w="19050">
+            <a:solidFill>
+              <a:srgbClr val="E2E8F0"/>
+            </a:solidFill>
+          </a:ln>
+        </p:spPr>
+        <p:style>
+          <a:lnRef idx="1">
+            <a:schemeClr val="accent1"/>
+          </a:lnRef>
+          <a:fillRef idx="3">
+            <a:schemeClr val="accent1"/>
+          </a:fillRef>
+          <a:effectRef idx="2">
+            <a:schemeClr val="accent1"/>
+          </a:effectRef>
+          <a:fontRef idx="minor">
+            <a:schemeClr val="lt1"/>
+          </a:fontRef>
+        </p:style>
+        <p:txBody>
+          <a:bodyPr rtlCol="0" anchor="ctr"/>
+          <a:lstStyle/>
+          <a:p>
+            <a:pPr algn="ctr"/>
+          </a:p>
+        </p:txBody>
+      </p:sp>
+      <p:sp>
+        <p:nvSpPr>
+          <p:cNvPr id="7" name="TextBox 6"/>
+          <p:cNvSpPr txBox="1"/>
+          <p:nvPr/>
+        </p:nvSpPr>
+        <p:spPr>
+          <a:xfrm>
+            <a:off x="6400800" y="1645920"/>
+            <a:ext cx="4846320" cy="4480560"/>
           </a:xfrm>
           <a:prstGeom prst="rect">
             <a:avLst/>
           </a:prstGeom>
-        </p:spPr>
-      </p:pic>
+          <a:noFill/>
+        </p:spPr>
+        <p:txBody>
+          <a:bodyPr wrap="square">
+            <a:spAutoFit/>
+          </a:bodyPr>
+          <a:lstStyle/>
+          <a:p>
+            <a:pPr>
+              <a:spcAft>
+                <a:spcPts val="1000"/>
+              </a:spcAft>
+              <a:defRPr sz="1600" b="1">
+                <a:solidFill>
+                  <a:srgbClr val="10B981"/>
+                </a:solidFill>
+                <a:latin typeface="Arial"/>
+              </a:defRPr>
+            </a:pPr>
+            <a:r>
+              <a:t>Clinical Impact &amp; Benefits</a:t>
+            </a:r>
+          </a:p>
+          <a:p>
+            <a:pPr>
+              <a:spcAft>
+                <a:spcPts val="600"/>
+              </a:spcAft>
+              <a:defRPr>
+                <a:latin typeface="Arial"/>
+              </a:defRPr>
+            </a:pPr>
+            <a:r>
+              <a:rPr b="1" sz="1200">
+                <a:solidFill>
+                  <a:srgbClr val="0F172A"/>
+                </a:solidFill>
+              </a:rPr>
+              <a:t>• Reduced Diagnostic Errors: </a:t>
+            </a:r>
+            <a:r>
+              <a:rPr b="0" sz="1200">
+                <a:solidFill>
+                  <a:srgbClr val="475569"/>
+                </a:solidFill>
+              </a:rPr>
+              <a:t>Improves preliminary accuracy by systematically querying secondary signs.</a:t>
+            </a:r>
+          </a:p>
+          <a:p>
+            <a:pPr>
+              <a:spcAft>
+                <a:spcPts val="600"/>
+              </a:spcAft>
+              <a:defRPr>
+                <a:latin typeface="Arial"/>
+              </a:defRPr>
+            </a:pPr>
+            <a:r>
+              <a:rPr b="1" sz="1200">
+                <a:solidFill>
+                  <a:srgbClr val="0F172A"/>
+                </a:solidFill>
+              </a:rPr>
+              <a:t>• High-Yield Test Selection: </a:t>
+            </a:r>
+            <a:r>
+              <a:rPr b="0" sz="1200">
+                <a:solidFill>
+                  <a:srgbClr val="475569"/>
+                </a:solidFill>
+              </a:rPr>
+              <a:t>Recommends specific high-yield lab investigations (e.g. Widal, Dengue NS1).</a:t>
+            </a:r>
+          </a:p>
+          <a:p>
+            <a:pPr>
+              <a:spcAft>
+                <a:spcPts val="600"/>
+              </a:spcAft>
+              <a:defRPr>
+                <a:latin typeface="Arial"/>
+              </a:defRPr>
+            </a:pPr>
+            <a:r>
+              <a:rPr b="1" sz="1200">
+                <a:solidFill>
+                  <a:srgbClr val="0F172A"/>
+                </a:solidFill>
+              </a:rPr>
+              <a:t>• Treatment Safety Protocol: </a:t>
+            </a:r>
+            <a:r>
+              <a:rPr b="0" sz="1200">
+                <a:solidFill>
+                  <a:srgbClr val="475569"/>
+                </a:solidFill>
+              </a:rPr>
+              <a:t>Displays immediate first-aid, dosage guidelines, and contraindications.</a:t>
+            </a:r>
+          </a:p>
+          <a:p>
+            <a:pPr>
+              <a:spcAft>
+                <a:spcPts val="600"/>
+              </a:spcAft>
+              <a:defRPr>
+                <a:latin typeface="Arial"/>
+              </a:defRPr>
+            </a:pPr>
+            <a:r>
+              <a:rPr b="1" sz="1200">
+                <a:solidFill>
+                  <a:srgbClr val="0F172A"/>
+                </a:solidFill>
+              </a:rPr>
+              <a:t>• Seamless Workstation UX: </a:t>
+            </a:r>
+            <a:r>
+              <a:rPr b="0" sz="1200">
+                <a:solidFill>
+                  <a:srgbClr val="475569"/>
+                </a:solidFill>
+              </a:rPr>
+              <a:t>Provides a clean clinician portal with persistent account storage.</a:t>
+            </a:r>
+          </a:p>
+        </p:txBody>
+      </p:sp>
     </p:spTree>
   </p:cSld>
   <p:clrMapOvr>
@@ -3922,7 +4801,7 @@
               </a:defRPr>
             </a:pPr>
             <a:r>
-              <a:t>MEDICAL DIAGNOSIS SYSTEM</a:t>
+              <a:t>MEDICAL DIAGNOSIS EXPERT SYSTEM</a:t>
             </a:r>
           </a:p>
         </p:txBody>
@@ -3958,29 +4837,29 @@
               </a:defRPr>
             </a:pPr>
             <a:r>
-              <a:t>Phase 2: Sequential Targeted Questioning</a:t>
-            </a:r>
-          </a:p>
-        </p:txBody>
-      </p:sp>
-      <p:sp>
-        <p:nvSpPr>
-          <p:cNvPr id="4" name="Rectangle 3"/>
+              <a:t>System Architecture &amp; Core Modules</a:t>
+            </a:r>
+          </a:p>
+        </p:txBody>
+      </p:sp>
+      <p:sp>
+        <p:nvSpPr>
+          <p:cNvPr id="4" name="Rounded Rectangle 3"/>
           <p:cNvSpPr/>
           <p:nvPr/>
         </p:nvSpPr>
         <p:spPr>
           <a:xfrm>
             <a:off x="731520" y="1463040"/>
-            <a:ext cx="4389120" cy="4846320"/>
-          </a:xfrm>
-          <a:prstGeom prst="rect">
+            <a:ext cx="3291840" cy="4846320"/>
+          </a:xfrm>
+          <a:prstGeom prst="roundRect">
             <a:avLst/>
           </a:prstGeom>
           <a:solidFill>
             <a:srgbClr val="FFFFFF"/>
           </a:solidFill>
-          <a:ln w="12700">
+          <a:ln w="19050">
             <a:solidFill>
               <a:srgbClr val="E2E8F0"/>
             </a:solidFill>
@@ -4017,7 +4896,7 @@
         <p:spPr>
           <a:xfrm>
             <a:off x="914400" y="1645920"/>
-            <a:ext cx="4023360" cy="4480560"/>
+            <a:ext cx="2926080" cy="4480560"/>
           </a:xfrm>
           <a:prstGeom prst="rect">
             <a:avLst/>
@@ -4036,13 +4915,13 @@
               </a:spcAft>
               <a:defRPr sz="1600" b="1">
                 <a:solidFill>
-                  <a:srgbClr val="10B981"/>
-                </a:solidFill>
-                <a:latin typeface="Arial"/>
-              </a:defRPr>
-            </a:pPr>
-            <a:r>
-              <a:t>Targeted Survey Design</a:t>
+                  <a:srgbClr val="6366F1"/>
+                </a:solidFill>
+                <a:latin typeface="Arial"/>
+              </a:defRPr>
+            </a:pPr>
+            <a:r>
+              <a:t>1. Knowledge Base</a:t>
             </a:r>
           </a:p>
           <a:p>
@@ -4060,7 +4939,7 @@
                   <a:srgbClr val="0F172A"/>
                 </a:solidFill>
               </a:rPr>
-              <a:t>• 3-Disease Lock: </a:t>
+              <a:t>• Kanren Relational Engine: </a:t>
             </a:r>
             <a:r>
               <a:rPr b="0" sz="1200">
@@ -4068,7 +4947,7 @@
                   <a:srgbClr val="475569"/>
                 </a:solidFill>
               </a:rPr>
-              <a:t>Locks top candidate conditions (Disease 3 to Disease 1 priority).</a:t>
+              <a:t>Python logic programming engine using relations, facts, and rules.</a:t>
             </a:r>
           </a:p>
           <a:p>
@@ -4086,7 +4965,7 @@
                   <a:srgbClr val="0F172A"/>
                 </a:solidFill>
               </a:rPr>
-              <a:t>• Binary Yes/No Cards: </a:t>
+              <a:t>• Medical Facts Dictionary: </a:t>
             </a:r>
             <a:r>
               <a:rPr b="0" sz="1200">
@@ -4094,7 +4973,7 @@
                   <a:srgbClr val="475569"/>
                 </a:solidFill>
               </a:rPr>
-              <a:t>Presents follow-up questions with clear Yes and No action buttons.</a:t>
+              <a:t>Disease profiles, ICD-10 codes, descriptions, and treatment protocols.</a:t>
             </a:r>
           </a:p>
           <a:p>
@@ -4112,7 +4991,7 @@
                   <a:srgbClr val="0F172A"/>
                 </a:solidFill>
               </a:rPr>
-              <a:t>• 5-Item Pagination: </a:t>
+              <a:t>• Rule Evaluator: </a:t>
             </a:r>
             <a:r>
               <a:rPr b="0" sz="1200">
@@ -4120,61 +4999,361 @@
                   <a:srgbClr val="475569"/>
                 </a:solidFill>
               </a:rPr>
-              <a:t>Displays at most 5 questions per page when total questions &gt; 5.</a:t>
-            </a:r>
-          </a:p>
-          <a:p>
-            <a:pPr>
-              <a:spcAft>
-                <a:spcPts val="600"/>
-              </a:spcAft>
-              <a:defRPr>
-                <a:latin typeface="Arial"/>
-              </a:defRPr>
-            </a:pPr>
-            <a:r>
-              <a:rPr b="1" sz="1200">
-                <a:solidFill>
-                  <a:srgbClr val="0F172A"/>
-                </a:solidFill>
-              </a:rPr>
-              <a:t>• Progress Tracking: </a:t>
-            </a:r>
-            <a:r>
-              <a:rPr b="0" sz="1200">
-                <a:solidFill>
-                  <a:srgbClr val="475569"/>
-                </a:solidFill>
-              </a:rPr>
-              <a:t>Monitors active completion progress.</a:t>
-            </a:r>
-          </a:p>
-        </p:txBody>
-      </p:sp>
-      <p:pic>
-        <p:nvPicPr>
-          <p:cNvPr id="6" name="Picture 5" descr="app_sequential_questions_1786061602441.jpg"/>
-          <p:cNvPicPr>
-            <a:picLocks noChangeAspect="1"/>
-          </p:cNvPicPr>
+              <a:t>Declarative rules mapping symptom combinations to disease confidence.</a:t>
+            </a:r>
+          </a:p>
+        </p:txBody>
+      </p:sp>
+      <p:sp>
+        <p:nvSpPr>
+          <p:cNvPr id="6" name="Rounded Rectangle 5"/>
+          <p:cNvSpPr/>
           <p:nvPr/>
-        </p:nvPicPr>
-        <p:blipFill>
-          <a:blip r:embed="rId2"/>
-          <a:stretch>
-            <a:fillRect/>
-          </a:stretch>
-        </p:blipFill>
-        <p:spPr>
-          <a:xfrm>
-            <a:off x="5394960" y="1463040"/>
-            <a:ext cx="6035040" cy="3368394"/>
+        </p:nvSpPr>
+        <p:spPr>
+          <a:xfrm>
+            <a:off x="4389120" y="1463040"/>
+            <a:ext cx="3291840" cy="4846320"/>
+          </a:xfrm>
+          <a:prstGeom prst="roundRect">
+            <a:avLst/>
+          </a:prstGeom>
+          <a:solidFill>
+            <a:srgbClr val="FFFFFF"/>
+          </a:solidFill>
+          <a:ln w="19050">
+            <a:solidFill>
+              <a:srgbClr val="E2E8F0"/>
+            </a:solidFill>
+          </a:ln>
+        </p:spPr>
+        <p:style>
+          <a:lnRef idx="1">
+            <a:schemeClr val="accent1"/>
+          </a:lnRef>
+          <a:fillRef idx="3">
+            <a:schemeClr val="accent1"/>
+          </a:fillRef>
+          <a:effectRef idx="2">
+            <a:schemeClr val="accent1"/>
+          </a:effectRef>
+          <a:fontRef idx="minor">
+            <a:schemeClr val="lt1"/>
+          </a:fontRef>
+        </p:style>
+        <p:txBody>
+          <a:bodyPr rtlCol="0" anchor="ctr"/>
+          <a:lstStyle/>
+          <a:p>
+            <a:pPr algn="ctr"/>
+          </a:p>
+        </p:txBody>
+      </p:sp>
+      <p:sp>
+        <p:nvSpPr>
+          <p:cNvPr id="7" name="TextBox 6"/>
+          <p:cNvSpPr txBox="1"/>
+          <p:nvPr/>
+        </p:nvSpPr>
+        <p:spPr>
+          <a:xfrm>
+            <a:off x="4572000" y="1645920"/>
+            <a:ext cx="2926080" cy="4480560"/>
           </a:xfrm>
           <a:prstGeom prst="rect">
             <a:avLst/>
           </a:prstGeom>
-        </p:spPr>
-      </p:pic>
+          <a:noFill/>
+        </p:spPr>
+        <p:txBody>
+          <a:bodyPr wrap="square">
+            <a:spAutoFit/>
+          </a:bodyPr>
+          <a:lstStyle/>
+          <a:p>
+            <a:pPr>
+              <a:spcAft>
+                <a:spcPts val="1000"/>
+              </a:spcAft>
+              <a:defRPr sz="1600" b="1">
+                <a:solidFill>
+                  <a:srgbClr val="0EA5E9"/>
+                </a:solidFill>
+                <a:latin typeface="Arial"/>
+              </a:defRPr>
+            </a:pPr>
+            <a:r>
+              <a:t>2. REST API Engine</a:t>
+            </a:r>
+          </a:p>
+          <a:p>
+            <a:pPr>
+              <a:spcAft>
+                <a:spcPts val="600"/>
+              </a:spcAft>
+              <a:defRPr>
+                <a:latin typeface="Arial"/>
+              </a:defRPr>
+            </a:pPr>
+            <a:r>
+              <a:rPr b="1" sz="1200">
+                <a:solidFill>
+                  <a:srgbClr val="0F172A"/>
+                </a:solidFill>
+              </a:rPr>
+              <a:t>• Flask/FastAPI Backend: </a:t>
+            </a:r>
+            <a:r>
+              <a:rPr b="0" sz="1200">
+                <a:solidFill>
+                  <a:srgbClr val="475569"/>
+                </a:solidFill>
+              </a:rPr>
+              <a:t>Exposes structured HTTP API endpoints for web/mobile client access.</a:t>
+            </a:r>
+          </a:p>
+          <a:p>
+            <a:pPr>
+              <a:spcAft>
+                <a:spcPts val="600"/>
+              </a:spcAft>
+              <a:defRPr>
+                <a:latin typeface="Arial"/>
+              </a:defRPr>
+            </a:pPr>
+            <a:r>
+              <a:rPr b="1" sz="1200">
+                <a:solidFill>
+                  <a:srgbClr val="0F172A"/>
+                </a:solidFill>
+              </a:rPr>
+              <a:t>• /api/v1/diagnose: </a:t>
+            </a:r>
+            <a:r>
+              <a:rPr b="0" sz="1200">
+                <a:solidFill>
+                  <a:srgbClr val="475569"/>
+                </a:solidFill>
+              </a:rPr>
+              <a:t>Processes symptom intake and ranks candidate conditions.</a:t>
+            </a:r>
+          </a:p>
+          <a:p>
+            <a:pPr>
+              <a:spcAft>
+                <a:spcPts val="600"/>
+              </a:spcAft>
+              <a:defRPr>
+                <a:latin typeface="Arial"/>
+              </a:defRPr>
+            </a:pPr>
+            <a:r>
+              <a:rPr b="1" sz="1200">
+                <a:solidFill>
+                  <a:srgbClr val="0F172A"/>
+                </a:solidFill>
+              </a:rPr>
+              <a:t>• /api/v1/next-questions: </a:t>
+            </a:r>
+            <a:r>
+              <a:rPr b="0" sz="1200">
+                <a:solidFill>
+                  <a:srgbClr val="475569"/>
+                </a:solidFill>
+              </a:rPr>
+              <a:t>Generates targeted follow-up questions.</a:t>
+            </a:r>
+          </a:p>
+          <a:p>
+            <a:pPr>
+              <a:spcAft>
+                <a:spcPts val="600"/>
+              </a:spcAft>
+              <a:defRPr>
+                <a:latin typeface="Arial"/>
+              </a:defRPr>
+            </a:pPr>
+            <a:r>
+              <a:rPr b="1" sz="1200">
+                <a:solidFill>
+                  <a:srgbClr val="0F172A"/>
+                </a:solidFill>
+              </a:rPr>
+              <a:t>• /api/v1/testing-result: </a:t>
+            </a:r>
+            <a:r>
+              <a:rPr b="0" sz="1200">
+                <a:solidFill>
+                  <a:srgbClr val="475569"/>
+                </a:solidFill>
+              </a:rPr>
+              <a:t>Evaluates lab test outcomes and updates the remaining pool.</a:t>
+            </a:r>
+          </a:p>
+        </p:txBody>
+      </p:sp>
+      <p:sp>
+        <p:nvSpPr>
+          <p:cNvPr id="8" name="Rounded Rectangle 7"/>
+          <p:cNvSpPr/>
+          <p:nvPr/>
+        </p:nvSpPr>
+        <p:spPr>
+          <a:xfrm>
+            <a:off x="8046720" y="1463040"/>
+            <a:ext cx="3383280" cy="4846320"/>
+          </a:xfrm>
+          <a:prstGeom prst="roundRect">
+            <a:avLst/>
+          </a:prstGeom>
+          <a:solidFill>
+            <a:srgbClr val="FFFFFF"/>
+          </a:solidFill>
+          <a:ln w="19050">
+            <a:solidFill>
+              <a:srgbClr val="E2E8F0"/>
+            </a:solidFill>
+          </a:ln>
+        </p:spPr>
+        <p:style>
+          <a:lnRef idx="1">
+            <a:schemeClr val="accent1"/>
+          </a:lnRef>
+          <a:fillRef idx="3">
+            <a:schemeClr val="accent1"/>
+          </a:fillRef>
+          <a:effectRef idx="2">
+            <a:schemeClr val="accent1"/>
+          </a:effectRef>
+          <a:fontRef idx="minor">
+            <a:schemeClr val="lt1"/>
+          </a:fontRef>
+        </p:style>
+        <p:txBody>
+          <a:bodyPr rtlCol="0" anchor="ctr"/>
+          <a:lstStyle/>
+          <a:p>
+            <a:pPr algn="ctr"/>
+          </a:p>
+        </p:txBody>
+      </p:sp>
+      <p:sp>
+        <p:nvSpPr>
+          <p:cNvPr id="9" name="TextBox 8"/>
+          <p:cNvSpPr txBox="1"/>
+          <p:nvPr/>
+        </p:nvSpPr>
+        <p:spPr>
+          <a:xfrm>
+            <a:off x="8229600" y="1645920"/>
+            <a:ext cx="3017520" cy="4480560"/>
+          </a:xfrm>
+          <a:prstGeom prst="rect">
+            <a:avLst/>
+          </a:prstGeom>
+          <a:noFill/>
+        </p:spPr>
+        <p:txBody>
+          <a:bodyPr wrap="square">
+            <a:spAutoFit/>
+          </a:bodyPr>
+          <a:lstStyle/>
+          <a:p>
+            <a:pPr>
+              <a:spcAft>
+                <a:spcPts val="1000"/>
+              </a:spcAft>
+              <a:defRPr sz="1600" b="1">
+                <a:solidFill>
+                  <a:srgbClr val="10B981"/>
+                </a:solidFill>
+                <a:latin typeface="Arial"/>
+              </a:defRPr>
+            </a:pPr>
+            <a:r>
+              <a:t>3. Web Workstation UI</a:t>
+            </a:r>
+          </a:p>
+          <a:p>
+            <a:pPr>
+              <a:spcAft>
+                <a:spcPts val="600"/>
+              </a:spcAft>
+              <a:defRPr>
+                <a:latin typeface="Arial"/>
+              </a:defRPr>
+            </a:pPr>
+            <a:r>
+              <a:rPr b="1" sz="1200">
+                <a:solidFill>
+                  <a:srgbClr val="0F172A"/>
+                </a:solidFill>
+              </a:rPr>
+              <a:t>• HTML5 &amp; Vanilla CSS: </a:t>
+            </a:r>
+            <a:r>
+              <a:rPr b="0" sz="1200">
+                <a:solidFill>
+                  <a:srgbClr val="475569"/>
+                </a:solidFill>
+              </a:rPr>
+              <a:t>Crisp light medical portal with responsive workspace design.</a:t>
+            </a:r>
+          </a:p>
+          <a:p>
+            <a:pPr>
+              <a:spcAft>
+                <a:spcPts val="600"/>
+              </a:spcAft>
+              <a:defRPr>
+                <a:latin typeface="Arial"/>
+              </a:defRPr>
+            </a:pPr>
+            <a:r>
+              <a:rPr b="1" sz="1200">
+                <a:solidFill>
+                  <a:srgbClr val="0F172A"/>
+                </a:solidFill>
+              </a:rPr>
+              <a:t>• JavaScript State Control: </a:t>
+            </a:r>
+            <a:r>
+              <a:rPr b="0" sz="1200">
+                <a:solidFill>
+                  <a:srgbClr val="475569"/>
+                </a:solidFill>
+              </a:rPr>
+              <a:t>Manages state, pagination, account storage, and API communication.</a:t>
+            </a:r>
+          </a:p>
+          <a:p>
+            <a:pPr>
+              <a:spcAft>
+                <a:spcPts val="600"/>
+              </a:spcAft>
+              <a:defRPr>
+                <a:latin typeface="Arial"/>
+              </a:defRPr>
+            </a:pPr>
+            <a:r>
+              <a:rPr b="1" sz="1200">
+                <a:solidFill>
+                  <a:srgbClr val="0F172A"/>
+                </a:solidFill>
+              </a:rPr>
+              <a:t>• Clinician Portal: </a:t>
+            </a:r>
+            <a:r>
+              <a:rPr b="0" sz="1200">
+                <a:solidFill>
+                  <a:srgbClr val="475569"/>
+                </a:solidFill>
+              </a:rPr>
+              <a:t>Provides secure login, collapsible sidebar, and diagnostic outputs.</a:t>
+            </a:r>
+          </a:p>
+        </p:txBody>
+      </p:sp>
     </p:spTree>
   </p:cSld>
   <p:clrMapOvr>
@@ -4232,7 +5411,7 @@
               </a:defRPr>
             </a:pPr>
             <a:r>
-              <a:t>MEDICAL DIAGNOSIS SYSTEM</a:t>
+              <a:t>MEDICAL DIAGNOSIS EXPERT SYSTEM</a:t>
             </a:r>
           </a:p>
         </p:txBody>
@@ -4268,29 +5447,29 @@
               </a:defRPr>
             </a:pPr>
             <a:r>
-              <a:t>Phase 3: Differential Output &amp; Lab Confirmation</a:t>
-            </a:r>
-          </a:p>
-        </p:txBody>
-      </p:sp>
-      <p:sp>
-        <p:nvSpPr>
-          <p:cNvPr id="4" name="Rectangle 3"/>
+              <a:t>Clinician Portal &amp; Account Storage</a:t>
+            </a:r>
+          </a:p>
+        </p:txBody>
+      </p:sp>
+      <p:sp>
+        <p:nvSpPr>
+          <p:cNvPr id="4" name="Rounded Rectangle 3"/>
           <p:cNvSpPr/>
           <p:nvPr/>
         </p:nvSpPr>
         <p:spPr>
           <a:xfrm>
             <a:off x="731520" y="1463040"/>
-            <a:ext cx="4389120" cy="4846320"/>
-          </a:xfrm>
-          <a:prstGeom prst="rect">
+            <a:ext cx="5120640" cy="4846320"/>
+          </a:xfrm>
+          <a:prstGeom prst="roundRect">
             <a:avLst/>
           </a:prstGeom>
           <a:solidFill>
             <a:srgbClr val="FFFFFF"/>
           </a:solidFill>
-          <a:ln w="12700">
+          <a:ln w="19050">
             <a:solidFill>
               <a:srgbClr val="E2E8F0"/>
             </a:solidFill>
@@ -4327,7 +5506,7 @@
         <p:spPr>
           <a:xfrm>
             <a:off x="914400" y="1645920"/>
-            <a:ext cx="4023360" cy="4480560"/>
+            <a:ext cx="4754880" cy="4480560"/>
           </a:xfrm>
           <a:prstGeom prst="rect">
             <a:avLst/>
@@ -4352,7 +5531,7 @@
               </a:defRPr>
             </a:pPr>
             <a:r>
-              <a:t>Diagnosis &amp; Testing Output</a:t>
+              <a:t>Authentication &amp; Credentials</a:t>
             </a:r>
           </a:p>
           <a:p>
@@ -4370,7 +5549,7 @@
                   <a:srgbClr val="0F172A"/>
                 </a:solidFill>
               </a:rPr>
-              <a:t>• Primary Diagnosis Card: </a:t>
+              <a:t>• Account Registration: </a:t>
             </a:r>
             <a:r>
               <a:rPr b="0" sz="1200">
@@ -4378,7 +5557,7 @@
                   <a:srgbClr val="475569"/>
                 </a:solidFill>
               </a:rPr>
-              <a:t>Displays leading condition, ICD-10 code, confidence %, description.</a:t>
+              <a:t>Clinicians register by providing full name, email, facility name, and password.</a:t>
             </a:r>
           </a:p>
           <a:p>
@@ -4396,7 +5575,7 @@
                   <a:srgbClr val="0F172A"/>
                 </a:solidFill>
               </a:rPr>
-              <a:t>• Recommended Tests: </a:t>
+              <a:t>• Secure Sign In: </a:t>
             </a:r>
             <a:r>
               <a:rPr b="0" sz="1200">
@@ -4404,7 +5583,7 @@
                   <a:srgbClr val="475569"/>
                 </a:solidFill>
               </a:rPr>
-              <a:t>Specifies laboratory test name, sample type, and urgency.</a:t>
+              <a:t>Registered clinicians sign in to launch their clinical workstation.</a:t>
             </a:r>
           </a:p>
           <a:p>
@@ -4422,7 +5601,7 @@
                   <a:srgbClr val="0F172A"/>
                 </a:solidFill>
               </a:rPr>
-              <a:t>• Confirmation Testing: </a:t>
+              <a:t>• Password Reset Recovery: </a:t>
             </a:r>
             <a:r>
               <a:rPr b="0" sz="1200">
@@ -4430,7 +5609,7 @@
                   <a:srgbClr val="475569"/>
                 </a:solidFill>
               </a:rPr>
-              <a:t>Processes Test Positive and Test Negative lab outcomes.</a:t>
+              <a:t>Includes a password reset request modal for credential recovery.</a:t>
             </a:r>
           </a:p>
           <a:p>
@@ -4448,7 +5627,7 @@
                   <a:srgbClr val="0F172A"/>
                 </a:solidFill>
               </a:rPr>
-              <a:t>• Confirmed State: </a:t>
+              <a:t>• localStorage Persistence: </a:t>
             </a:r>
             <a:r>
               <a:rPr b="0" sz="1200">
@@ -4456,35 +5635,173 @@
                   <a:srgbClr val="475569"/>
                 </a:solidFill>
               </a:rPr>
-              <a:t>Locks confirmed disease and displays prescribed medications.</a:t>
-            </a:r>
-          </a:p>
-        </p:txBody>
-      </p:sp>
-      <p:pic>
-        <p:nvPicPr>
-          <p:cNvPr id="6" name="Picture 5" descr="app_diagnosis_results_1786061625925.jpg"/>
-          <p:cNvPicPr>
-            <a:picLocks noChangeAspect="1"/>
-          </p:cNvPicPr>
+              <a:t>Account profiles persist in browser storage across page reloads.</a:t>
+            </a:r>
+          </a:p>
+        </p:txBody>
+      </p:sp>
+      <p:sp>
+        <p:nvSpPr>
+          <p:cNvPr id="6" name="Rounded Rectangle 5"/>
+          <p:cNvSpPr/>
           <p:nvPr/>
-        </p:nvPicPr>
-        <p:blipFill>
-          <a:blip r:embed="rId2"/>
-          <a:stretch>
-            <a:fillRect/>
-          </a:stretch>
-        </p:blipFill>
-        <p:spPr>
-          <a:xfrm>
-            <a:off x="5394960" y="1463040"/>
-            <a:ext cx="6035040" cy="3368394"/>
+        </p:nvSpPr>
+        <p:spPr>
+          <a:xfrm>
+            <a:off x="6217920" y="1463040"/>
+            <a:ext cx="5212080" cy="4846320"/>
+          </a:xfrm>
+          <a:prstGeom prst="roundRect">
+            <a:avLst/>
+          </a:prstGeom>
+          <a:solidFill>
+            <a:srgbClr val="FFFFFF"/>
+          </a:solidFill>
+          <a:ln w="19050">
+            <a:solidFill>
+              <a:srgbClr val="E2E8F0"/>
+            </a:solidFill>
+          </a:ln>
+        </p:spPr>
+        <p:style>
+          <a:lnRef idx="1">
+            <a:schemeClr val="accent1"/>
+          </a:lnRef>
+          <a:fillRef idx="3">
+            <a:schemeClr val="accent1"/>
+          </a:fillRef>
+          <a:effectRef idx="2">
+            <a:schemeClr val="accent1"/>
+          </a:effectRef>
+          <a:fontRef idx="minor">
+            <a:schemeClr val="lt1"/>
+          </a:fontRef>
+        </p:style>
+        <p:txBody>
+          <a:bodyPr rtlCol="0" anchor="ctr"/>
+          <a:lstStyle/>
+          <a:p>
+            <a:pPr algn="ctr"/>
+          </a:p>
+        </p:txBody>
+      </p:sp>
+      <p:sp>
+        <p:nvSpPr>
+          <p:cNvPr id="7" name="TextBox 6"/>
+          <p:cNvSpPr txBox="1"/>
+          <p:nvPr/>
+        </p:nvSpPr>
+        <p:spPr>
+          <a:xfrm>
+            <a:off x="6400800" y="1645920"/>
+            <a:ext cx="4846320" cy="4480560"/>
           </a:xfrm>
           <a:prstGeom prst="rect">
             <a:avLst/>
           </a:prstGeom>
-        </p:spPr>
-      </p:pic>
+          <a:noFill/>
+        </p:spPr>
+        <p:txBody>
+          <a:bodyPr wrap="square">
+            <a:spAutoFit/>
+          </a:bodyPr>
+          <a:lstStyle/>
+          <a:p>
+            <a:pPr>
+              <a:spcAft>
+                <a:spcPts val="1000"/>
+              </a:spcAft>
+              <a:defRPr sz="1600" b="1">
+                <a:solidFill>
+                  <a:srgbClr val="6366F1"/>
+                </a:solidFill>
+                <a:latin typeface="Arial"/>
+              </a:defRPr>
+            </a:pPr>
+            <a:r>
+              <a:t>Clinician Workspace Sidebar</a:t>
+            </a:r>
+          </a:p>
+          <a:p>
+            <a:pPr>
+              <a:spcAft>
+                <a:spcPts val="600"/>
+              </a:spcAft>
+              <a:defRPr>
+                <a:latin typeface="Arial"/>
+              </a:defRPr>
+            </a:pPr>
+            <a:r>
+              <a:rPr b="1" sz="1200">
+                <a:solidFill>
+                  <a:srgbClr val="0F172A"/>
+                </a:solidFill>
+              </a:rPr>
+              <a:t>• Collapsible Sidebar Mode: </a:t>
+            </a:r>
+            <a:r>
+              <a:rPr b="0" sz="1200">
+                <a:solidFill>
+                  <a:srgbClr val="475569"/>
+                </a:solidFill>
+              </a:rPr>
+              <a:t>Displays active clinician name, email, facility, and role. Can be collapsed into icon view.</a:t>
+            </a:r>
+          </a:p>
+          <a:p>
+            <a:pPr>
+              <a:spcAft>
+                <a:spcPts val="600"/>
+              </a:spcAft>
+              <a:defRPr>
+                <a:latin typeface="Arial"/>
+              </a:defRPr>
+            </a:pPr>
+            <a:r>
+              <a:rPr b="1" sz="1200">
+                <a:solidFill>
+                  <a:srgbClr val="0F172A"/>
+                </a:solidFill>
+              </a:rPr>
+              <a:t>• Sign Out Control: </a:t>
+            </a:r>
+            <a:r>
+              <a:rPr b="0" sz="1200">
+                <a:solidFill>
+                  <a:srgbClr val="475569"/>
+                </a:solidFill>
+              </a:rPr>
+              <a:t>Located at the bottom of the sidebar to exit securely to the Landing Page.</a:t>
+            </a:r>
+          </a:p>
+          <a:p>
+            <a:pPr>
+              <a:spcAft>
+                <a:spcPts val="600"/>
+              </a:spcAft>
+              <a:defRPr>
+                <a:latin typeface="Arial"/>
+              </a:defRPr>
+            </a:pPr>
+            <a:r>
+              <a:rPr b="1" sz="1200">
+                <a:solidFill>
+                  <a:srgbClr val="0F172A"/>
+                </a:solidFill>
+              </a:rPr>
+              <a:t>• Status Bar Indicator: </a:t>
+            </a:r>
+            <a:r>
+              <a:rPr b="0" sz="1200">
+                <a:solidFill>
+                  <a:srgbClr val="475569"/>
+                </a:solidFill>
+              </a:rPr>
+              <a:t>Shows engine connection health (Online / Ready) in the top navigation bar.</a:t>
+            </a:r>
+          </a:p>
+        </p:txBody>
+      </p:sp>
     </p:spTree>
   </p:cSld>
   <p:clrMapOvr>
@@ -4499,7 +5816,7 @@
     <p:bg>
       <p:bgPr>
         <a:solidFill>
-          <a:srgbClr val="0F172A"/>
+          <a:srgbClr val="F8FAFC"/>
         </a:solidFill>
         <a:effectLst/>
       </p:bgPr>
@@ -4519,8 +5836,8 @@
         </p:nvSpPr>
         <p:spPr>
           <a:xfrm>
-            <a:off x="731520" y="1097280"/>
-            <a:ext cx="10698480" cy="548640"/>
+            <a:off x="731520" y="365760"/>
+            <a:ext cx="10698480" cy="365760"/>
           </a:xfrm>
           <a:prstGeom prst="rect">
             <a:avLst/>
@@ -4534,36 +5851,73 @@
           <a:lstStyle/>
           <a:p>
             <a:pPr>
-              <a:defRPr sz="1400" b="1">
+              <a:defRPr sz="1000" b="1">
                 <a:solidFill>
                   <a:srgbClr val="0EA5E9"/>
                 </a:solidFill>
-              </a:defRPr>
-            </a:pPr>
-            <a:r>
-              <a:t>TECHNICAL ARCHITECTURE &amp; VERIFICATION</a:t>
-            </a:r>
-          </a:p>
-        </p:txBody>
-      </p:sp>
-      <p:sp>
-        <p:nvSpPr>
-          <p:cNvPr id="3" name="Rectangle 2"/>
+                <a:latin typeface="Arial"/>
+              </a:defRPr>
+            </a:pPr>
+            <a:r>
+              <a:t>MEDICAL DIAGNOSIS EXPERT SYSTEM</a:t>
+            </a:r>
+          </a:p>
+        </p:txBody>
+      </p:sp>
+      <p:sp>
+        <p:nvSpPr>
+          <p:cNvPr id="3" name="TextBox 2"/>
+          <p:cNvSpPr txBox="1"/>
+          <p:nvPr/>
+        </p:nvSpPr>
+        <p:spPr>
+          <a:xfrm>
+            <a:off x="731520" y="685800"/>
+            <a:ext cx="10698480" cy="640080"/>
+          </a:xfrm>
+          <a:prstGeom prst="rect">
+            <a:avLst/>
+          </a:prstGeom>
+          <a:noFill/>
+        </p:spPr>
+        <p:txBody>
+          <a:bodyPr wrap="none">
+            <a:spAutoFit/>
+          </a:bodyPr>
+          <a:lstStyle/>
+          <a:p>
+            <a:pPr>
+              <a:defRPr sz="2400" b="1">
+                <a:solidFill>
+                  <a:srgbClr val="0F172A"/>
+                </a:solidFill>
+                <a:latin typeface="Arial"/>
+              </a:defRPr>
+            </a:pPr>
+            <a:r>
+              <a:t>Phase 1: Presenting Symptom Intake</a:t>
+            </a:r>
+          </a:p>
+        </p:txBody>
+      </p:sp>
+      <p:sp>
+        <p:nvSpPr>
+          <p:cNvPr id="4" name="Rounded Rectangle 3"/>
           <p:cNvSpPr/>
           <p:nvPr/>
         </p:nvSpPr>
         <p:spPr>
           <a:xfrm>
-            <a:off x="731520" y="1828800"/>
-            <a:ext cx="3291840" cy="4389120"/>
-          </a:xfrm>
-          <a:prstGeom prst="rect">
+            <a:off x="731520" y="1463040"/>
+            <a:ext cx="3291840" cy="4846320"/>
+          </a:xfrm>
+          <a:prstGeom prst="roundRect">
             <a:avLst/>
           </a:prstGeom>
           <a:solidFill>
             <a:srgbClr val="FFFFFF"/>
           </a:solidFill>
-          <a:ln w="12700">
+          <a:ln w="19050">
             <a:solidFill>
               <a:srgbClr val="E2E8F0"/>
             </a:solidFill>
@@ -4593,14 +5947,14 @@
       </p:sp>
       <p:sp>
         <p:nvSpPr>
-          <p:cNvPr id="4" name="TextBox 3"/>
+          <p:cNvPr id="5" name="TextBox 4"/>
           <p:cNvSpPr txBox="1"/>
           <p:nvPr/>
         </p:nvSpPr>
         <p:spPr>
           <a:xfrm>
-            <a:off x="914400" y="2011680"/>
-            <a:ext cx="2926080" cy="4023360"/>
+            <a:off x="914400" y="1645920"/>
+            <a:ext cx="2926080" cy="4480560"/>
           </a:xfrm>
           <a:prstGeom prst="rect">
             <a:avLst/>
@@ -4625,7 +5979,7 @@
               </a:defRPr>
             </a:pPr>
             <a:r>
-              <a:t>Python Kanren Engine</a:t>
+              <a:t>Symptom Categories</a:t>
             </a:r>
           </a:p>
           <a:p>
@@ -4643,7 +5997,7 @@
                   <a:srgbClr val="0F172A"/>
                 </a:solidFill>
               </a:rPr>
-              <a:t>• Relational Facts: </a:t>
+              <a:t>• Systemic: </a:t>
             </a:r>
             <a:r>
               <a:rPr b="0" sz="1200">
@@ -4651,7 +6005,7 @@
                   <a:srgbClr val="475569"/>
                 </a:solidFill>
               </a:rPr>
-              <a:t>Disease definitions &amp; ICD-10 codes.</a:t>
+              <a:t>High fever, chills, fatigue, diaphoresis, rigors.</a:t>
             </a:r>
           </a:p>
           <a:p>
@@ -4669,7 +6023,7 @@
                   <a:srgbClr val="0F172A"/>
                 </a:solidFill>
               </a:rPr>
-              <a:t>• Logical Rules: </a:t>
+              <a:t>• Respiratory: </a:t>
             </a:r>
             <a:r>
               <a:rPr b="0" sz="1200">
@@ -4677,7 +6031,7 @@
                   <a:srgbClr val="475569"/>
                 </a:solidFill>
               </a:rPr>
-              <a:t>Relational symptom matching.</a:t>
+              <a:t>Cough, dyspnea, sore throat, anosmia.</a:t>
             </a:r>
           </a:p>
           <a:p>
@@ -4695,7 +6049,7 @@
                   <a:srgbClr val="0F172A"/>
                 </a:solidFill>
               </a:rPr>
-              <a:t>• Question Generator: </a:t>
+              <a:t>• Gastrointestinal: </a:t>
             </a:r>
             <a:r>
               <a:rPr b="0" sz="1200">
@@ -4703,29 +6057,55 @@
                   <a:srgbClr val="475569"/>
                 </a:solidFill>
               </a:rPr>
-              <a:t>Adaptive follow-up queries.</a:t>
-            </a:r>
-          </a:p>
-        </p:txBody>
-      </p:sp>
-      <p:sp>
-        <p:nvSpPr>
-          <p:cNvPr id="5" name="Rectangle 4"/>
+              <a:t>Abdominal pain, nausea, diarrhea, vomiting.</a:t>
+            </a:r>
+          </a:p>
+          <a:p>
+            <a:pPr>
+              <a:spcAft>
+                <a:spcPts val="600"/>
+              </a:spcAft>
+              <a:defRPr>
+                <a:latin typeface="Arial"/>
+              </a:defRPr>
+            </a:pPr>
+            <a:r>
+              <a:rPr b="1" sz="1200">
+                <a:solidFill>
+                  <a:srgbClr val="0F172A"/>
+                </a:solidFill>
+              </a:rPr>
+              <a:t>• Neurological: </a:t>
+            </a:r>
+            <a:r>
+              <a:rPr b="0" sz="1200">
+                <a:solidFill>
+                  <a:srgbClr val="475569"/>
+                </a:solidFill>
+              </a:rPr>
+              <a:t>Headache, retro-orbital pain, dizziness.</a:t>
+            </a:r>
+          </a:p>
+        </p:txBody>
+      </p:sp>
+      <p:sp>
+        <p:nvSpPr>
+          <p:cNvPr id="6" name="Rounded Rectangle 5"/>
           <p:cNvSpPr/>
           <p:nvPr/>
         </p:nvSpPr>
         <p:spPr>
           <a:xfrm>
-            <a:off x="4389120" y="1828800"/>
-            <a:ext cx="3291840" cy="4389120"/>
-          </a:xfrm>
-          <a:prstGeom prst="rect">
+            <a:off x="4389120" y="1463040"/>
+            <a:ext cx="3291840" cy="4846320"/>
+          </a:xfrm>
+          <a:prstGeom prst="roundRect">
             <a:avLst/>
           </a:prstGeom>
           <a:solidFill>
             <a:srgbClr val="FFFFFF"/>
           </a:solidFill>
-          <a:ln w="12700">
+          <a:ln w="19050">
             <a:solidFill>
               <a:srgbClr val="E2E8F0"/>
             </a:solidFill>
@@ -4755,14 +6135,14 @@
       </p:sp>
       <p:sp>
         <p:nvSpPr>
-          <p:cNvPr id="6" name="TextBox 5"/>
+          <p:cNvPr id="7" name="TextBox 6"/>
           <p:cNvSpPr txBox="1"/>
           <p:nvPr/>
         </p:nvSpPr>
         <p:spPr>
           <a:xfrm>
-            <a:off x="4572000" y="2011680"/>
-            <a:ext cx="2926080" cy="4023360"/>
+            <a:off x="4572000" y="1645920"/>
+            <a:ext cx="2926080" cy="4480560"/>
           </a:xfrm>
           <a:prstGeom prst="rect">
             <a:avLst/>
@@ -4781,13 +6161,13 @@
               </a:spcAft>
               <a:defRPr sz="1600" b="1">
                 <a:solidFill>
-                  <a:srgbClr val="4F46E5"/>
-                </a:solidFill>
-                <a:latin typeface="Arial"/>
-              </a:defRPr>
-            </a:pPr>
-            <a:r>
-              <a:t>REST API Backend</a:t>
+                  <a:srgbClr val="6366F1"/>
+                </a:solidFill>
+                <a:latin typeface="Arial"/>
+              </a:defRPr>
+            </a:pPr>
+            <a:r>
+              <a:t>Risk Factors &amp; History</a:t>
             </a:r>
           </a:p>
           <a:p>
@@ -4805,7 +6185,7 @@
                   <a:srgbClr val="0F172A"/>
                 </a:solidFill>
               </a:rPr>
-              <a:t>• /api/v1/diagnose: </a:t>
+              <a:t>• Vector Exposure: </a:t>
             </a:r>
             <a:r>
               <a:rPr b="0" sz="1200">
@@ -4813,7 +6193,7 @@
                   <a:srgbClr val="475569"/>
                 </a:solidFill>
               </a:rPr>
-              <a:t>Symptom triage endpoint.</a:t>
+              <a:t>Recent mosquito bites or travel to endemic areas.</a:t>
             </a:r>
           </a:p>
           <a:p>
@@ -4831,7 +6211,7 @@
                   <a:srgbClr val="0F172A"/>
                 </a:solidFill>
               </a:rPr>
-              <a:t>• /api/v1/next-questions: </a:t>
+              <a:t>• Water Hygiene: </a:t>
             </a:r>
             <a:r>
               <a:rPr b="0" sz="1200">
@@ -4839,7 +6219,7 @@
                   <a:srgbClr val="475569"/>
                 </a:solidFill>
               </a:rPr>
-              <a:t>Questioning endpoint.</a:t>
+              <a:t>Consumption of unboiled water or street food.</a:t>
             </a:r>
           </a:p>
           <a:p>
@@ -4857,7 +6237,7 @@
                   <a:srgbClr val="0F172A"/>
                 </a:solidFill>
               </a:rPr>
-              <a:t>• /api/v1/testing-result: </a:t>
+              <a:t>• Contact History: </a:t>
             </a:r>
             <a:r>
               <a:rPr b="0" sz="1200">
@@ -4865,29 +6245,55 @@
                   <a:srgbClr val="475569"/>
                 </a:solidFill>
               </a:rPr>
-              <a:t>Lab confirmation endpoint.</a:t>
-            </a:r>
-          </a:p>
-        </p:txBody>
-      </p:sp>
-      <p:sp>
-        <p:nvSpPr>
-          <p:cNvPr id="7" name="Rectangle 6"/>
+              <a:t>Contact with known infected individuals.</a:t>
+            </a:r>
+          </a:p>
+          <a:p>
+            <a:pPr>
+              <a:spcAft>
+                <a:spcPts val="600"/>
+              </a:spcAft>
+              <a:defRPr>
+                <a:latin typeface="Arial"/>
+              </a:defRPr>
+            </a:pPr>
+            <a:r>
+              <a:rPr b="1" sz="1200">
+                <a:solidFill>
+                  <a:srgbClr val="0F172A"/>
+                </a:solidFill>
+              </a:rPr>
+              <a:t>• Occupational Exposure: </a:t>
+            </a:r>
+            <a:r>
+              <a:rPr b="0" sz="1200">
+                <a:solidFill>
+                  <a:srgbClr val="475569"/>
+                </a:solidFill>
+              </a:rPr>
+              <a:t>Seasonal or healthcare setting risks.</a:t>
+            </a:r>
+          </a:p>
+        </p:txBody>
+      </p:sp>
+      <p:sp>
+        <p:nvSpPr>
+          <p:cNvPr id="8" name="Rounded Rectangle 7"/>
           <p:cNvSpPr/>
           <p:nvPr/>
         </p:nvSpPr>
         <p:spPr>
           <a:xfrm>
-            <a:off x="8046720" y="1828800"/>
-            <a:ext cx="3383280" cy="4389120"/>
-          </a:xfrm>
-          <a:prstGeom prst="rect">
+            <a:off x="8046720" y="1463040"/>
+            <a:ext cx="3383280" cy="4846320"/>
+          </a:xfrm>
+          <a:prstGeom prst="roundRect">
             <a:avLst/>
           </a:prstGeom>
           <a:solidFill>
             <a:srgbClr val="FFFFFF"/>
           </a:solidFill>
-          <a:ln w="12700">
+          <a:ln w="19050">
             <a:solidFill>
               <a:srgbClr val="E2E8F0"/>
             </a:solidFill>
@@ -4917,14 +6323,14 @@
       </p:sp>
       <p:sp>
         <p:nvSpPr>
-          <p:cNvPr id="8" name="TextBox 7"/>
+          <p:cNvPr id="9" name="TextBox 8"/>
           <p:cNvSpPr txBox="1"/>
           <p:nvPr/>
         </p:nvSpPr>
         <p:spPr>
           <a:xfrm>
-            <a:off x="8229600" y="2011680"/>
-            <a:ext cx="3017520" cy="4023360"/>
+            <a:off x="8229600" y="1645920"/>
+            <a:ext cx="3017520" cy="4480560"/>
           </a:xfrm>
           <a:prstGeom prst="rect">
             <a:avLst/>
@@ -4949,7 +6355,7 @@
               </a:defRPr>
             </a:pPr>
             <a:r>
-              <a:t>Quality Verification</a:t>
+              <a:t>Triage Controls</a:t>
             </a:r>
           </a:p>
           <a:p>
@@ -4967,7 +6373,7 @@
                   <a:srgbClr val="0F172A"/>
                 </a:solidFill>
               </a:rPr>
-              <a:t>• 9/9 Unit Tests: </a:t>
+              <a:t>• Interactive Checkboxes: </a:t>
             </a:r>
             <a:r>
               <a:rPr b="0" sz="1200">
@@ -4975,7 +6381,7 @@
                   <a:srgbClr val="475569"/>
                 </a:solidFill>
               </a:rPr>
-              <a:t>100% pass rate in test suite.</a:t>
+              <a:t>Fast click selection during patient intake.</a:t>
             </a:r>
           </a:p>
           <a:p>
@@ -4993,7 +6399,7 @@
                   <a:srgbClr val="0F172A"/>
                 </a:solidFill>
               </a:rPr>
-              <a:t>• 0 Syntax Errors: </a:t>
+              <a:t>• Custom Clinical Notes: </a:t>
             </a:r>
             <a:r>
               <a:rPr b="0" sz="1200">
@@ -5001,7 +6407,7 @@
                   <a:srgbClr val="475569"/>
                 </a:solidFill>
               </a:rPr>
-              <a:t>Node.js JS validation clean.</a:t>
+              <a:t>Text area for entering unlisted observations.</a:t>
             </a:r>
           </a:p>
           <a:p>
@@ -5019,7 +6425,7 @@
                   <a:srgbClr val="0F172A"/>
                 </a:solidFill>
               </a:rPr>
-              <a:t>• Flow Verified: </a:t>
+              <a:t>• Single-Click Execution: </a:t>
             </a:r>
             <a:r>
               <a:rPr b="0" sz="1200">
@@ -5027,7 +6433,1571 @@
                   <a:srgbClr val="475569"/>
                 </a:solidFill>
               </a:rPr>
-              <a:t>Auth, questioning, and lab test flows.</a:t>
+              <a:t>Triggers relational logic inference instantly.</a:t>
+            </a:r>
+          </a:p>
+        </p:txBody>
+      </p:sp>
+    </p:spTree>
+  </p:cSld>
+  <p:clrMapOvr>
+    <a:masterClrMapping/>
+  </p:clrMapOvr>
+</p:sld>
+</file>
+
+<file path=ppt/slides/slide7.xml><?xml version="1.0" encoding="utf-8"?>
+<p:sld xmlns:a="http://schemas.openxmlformats.org/drawingml/2006/main" xmlns:p="http://schemas.openxmlformats.org/presentationml/2006/main" xmlns:r="http://schemas.openxmlformats.org/officeDocument/2006/relationships">
+  <p:cSld>
+    <p:bg>
+      <p:bgPr>
+        <a:solidFill>
+          <a:srgbClr val="F8FAFC"/>
+        </a:solidFill>
+        <a:effectLst/>
+      </p:bgPr>
+    </p:bg>
+    <p:spTree>
+      <p:nvGrpSpPr>
+        <p:cNvPr id="1" name=""/>
+        <p:cNvGrpSpPr/>
+        <p:nvPr/>
+      </p:nvGrpSpPr>
+      <p:grpSpPr/>
+      <p:sp>
+        <p:nvSpPr>
+          <p:cNvPr id="2" name="TextBox 1"/>
+          <p:cNvSpPr txBox="1"/>
+          <p:nvPr/>
+        </p:nvSpPr>
+        <p:spPr>
+          <a:xfrm>
+            <a:off x="731520" y="365760"/>
+            <a:ext cx="10698480" cy="365760"/>
+          </a:xfrm>
+          <a:prstGeom prst="rect">
+            <a:avLst/>
+          </a:prstGeom>
+          <a:noFill/>
+        </p:spPr>
+        <p:txBody>
+          <a:bodyPr wrap="none">
+            <a:spAutoFit/>
+          </a:bodyPr>
+          <a:lstStyle/>
+          <a:p>
+            <a:pPr>
+              <a:defRPr sz="1000" b="1">
+                <a:solidFill>
+                  <a:srgbClr val="0EA5E9"/>
+                </a:solidFill>
+                <a:latin typeface="Arial"/>
+              </a:defRPr>
+            </a:pPr>
+            <a:r>
+              <a:t>MEDICAL DIAGNOSIS EXPERT SYSTEM</a:t>
+            </a:r>
+          </a:p>
+        </p:txBody>
+      </p:sp>
+      <p:sp>
+        <p:nvSpPr>
+          <p:cNvPr id="3" name="TextBox 2"/>
+          <p:cNvSpPr txBox="1"/>
+          <p:nvPr/>
+        </p:nvSpPr>
+        <p:spPr>
+          <a:xfrm>
+            <a:off x="731520" y="685800"/>
+            <a:ext cx="10698480" cy="640080"/>
+          </a:xfrm>
+          <a:prstGeom prst="rect">
+            <a:avLst/>
+          </a:prstGeom>
+          <a:noFill/>
+        </p:spPr>
+        <p:txBody>
+          <a:bodyPr wrap="none">
+            <a:spAutoFit/>
+          </a:bodyPr>
+          <a:lstStyle/>
+          <a:p>
+            <a:pPr>
+              <a:defRPr sz="2400" b="1">
+                <a:solidFill>
+                  <a:srgbClr val="0F172A"/>
+                </a:solidFill>
+                <a:latin typeface="Arial"/>
+              </a:defRPr>
+            </a:pPr>
+            <a:r>
+              <a:t>Phase 2: Sequential Targeted Questioning</a:t>
+            </a:r>
+          </a:p>
+        </p:txBody>
+      </p:sp>
+      <p:sp>
+        <p:nvSpPr>
+          <p:cNvPr id="4" name="Rounded Rectangle 3"/>
+          <p:cNvSpPr/>
+          <p:nvPr/>
+        </p:nvSpPr>
+        <p:spPr>
+          <a:xfrm>
+            <a:off x="731520" y="1463040"/>
+            <a:ext cx="5120640" cy="4846320"/>
+          </a:xfrm>
+          <a:prstGeom prst="roundRect">
+            <a:avLst/>
+          </a:prstGeom>
+          <a:solidFill>
+            <a:srgbClr val="FFFFFF"/>
+          </a:solidFill>
+          <a:ln w="19050">
+            <a:solidFill>
+              <a:srgbClr val="E2E8F0"/>
+            </a:solidFill>
+          </a:ln>
+        </p:spPr>
+        <p:style>
+          <a:lnRef idx="1">
+            <a:schemeClr val="accent1"/>
+          </a:lnRef>
+          <a:fillRef idx="3">
+            <a:schemeClr val="accent1"/>
+          </a:fillRef>
+          <a:effectRef idx="2">
+            <a:schemeClr val="accent1"/>
+          </a:effectRef>
+          <a:fontRef idx="minor">
+            <a:schemeClr val="lt1"/>
+          </a:fontRef>
+        </p:style>
+        <p:txBody>
+          <a:bodyPr rtlCol="0" anchor="ctr"/>
+          <a:lstStyle/>
+          <a:p>
+            <a:pPr algn="ctr"/>
+          </a:p>
+        </p:txBody>
+      </p:sp>
+      <p:sp>
+        <p:nvSpPr>
+          <p:cNvPr id="5" name="TextBox 4"/>
+          <p:cNvSpPr txBox="1"/>
+          <p:nvPr/>
+        </p:nvSpPr>
+        <p:spPr>
+          <a:xfrm>
+            <a:off x="914400" y="1645920"/>
+            <a:ext cx="4754880" cy="4480560"/>
+          </a:xfrm>
+          <a:prstGeom prst="rect">
+            <a:avLst/>
+          </a:prstGeom>
+          <a:noFill/>
+        </p:spPr>
+        <p:txBody>
+          <a:bodyPr wrap="square">
+            <a:spAutoFit/>
+          </a:bodyPr>
+          <a:lstStyle/>
+          <a:p>
+            <a:pPr>
+              <a:spcAft>
+                <a:spcPts val="1000"/>
+              </a:spcAft>
+              <a:defRPr sz="1600" b="1">
+                <a:solidFill>
+                  <a:srgbClr val="0EA5E9"/>
+                </a:solidFill>
+                <a:latin typeface="Arial"/>
+              </a:defRPr>
+            </a:pPr>
+            <a:r>
+              <a:t>Sequential Priority Algorithm</a:t>
+            </a:r>
+          </a:p>
+          <a:p>
+            <a:pPr>
+              <a:spcAft>
+                <a:spcPts val="600"/>
+              </a:spcAft>
+              <a:defRPr>
+                <a:latin typeface="Arial"/>
+              </a:defRPr>
+            </a:pPr>
+            <a:r>
+              <a:rPr b="1" sz="1200">
+                <a:solidFill>
+                  <a:srgbClr val="0F172A"/>
+                </a:solidFill>
+              </a:rPr>
+              <a:t>• Top 3 Candidate Lock: </a:t>
+            </a:r>
+            <a:r>
+              <a:rPr b="0" sz="1200">
+                <a:solidFill>
+                  <a:srgbClr val="475569"/>
+                </a:solidFill>
+              </a:rPr>
+              <a:t>Locks the top 3 candidate diseases matching initial symptoms.</a:t>
+            </a:r>
+          </a:p>
+          <a:p>
+            <a:pPr>
+              <a:spcAft>
+                <a:spcPts val="600"/>
+              </a:spcAft>
+              <a:defRPr>
+                <a:latin typeface="Arial"/>
+              </a:defRPr>
+            </a:pPr>
+            <a:r>
+              <a:rPr b="1" sz="1200">
+                <a:solidFill>
+                  <a:srgbClr val="0F172A"/>
+                </a:solidFill>
+              </a:rPr>
+              <a:t>• Least-Likely-First Priority: </a:t>
+            </a:r>
+            <a:r>
+              <a:rPr b="0" sz="1200">
+                <a:solidFill>
+                  <a:srgbClr val="475569"/>
+                </a:solidFill>
+              </a:rPr>
+              <a:t>Investigates Disease 3 -&gt; Disease 2 -&gt; Disease 1 to eliminate lower candidates early.</a:t>
+            </a:r>
+          </a:p>
+          <a:p>
+            <a:pPr>
+              <a:spcAft>
+                <a:spcPts val="600"/>
+              </a:spcAft>
+              <a:defRPr>
+                <a:latin typeface="Arial"/>
+              </a:defRPr>
+            </a:pPr>
+            <a:r>
+              <a:rPr b="1" sz="1200">
+                <a:solidFill>
+                  <a:srgbClr val="0F172A"/>
+                </a:solidFill>
+              </a:rPr>
+              <a:t>• Secondary Sign Queries: </a:t>
+            </a:r>
+            <a:r>
+              <a:rPr b="0" sz="1200">
+                <a:solidFill>
+                  <a:srgbClr val="475569"/>
+                </a:solidFill>
+              </a:rPr>
+              <a:t>Asks targeted follow-up questions regarding secondary signs.</a:t>
+            </a:r>
+          </a:p>
+          <a:p>
+            <a:pPr>
+              <a:spcAft>
+                <a:spcPts val="600"/>
+              </a:spcAft>
+              <a:defRPr>
+                <a:latin typeface="Arial"/>
+              </a:defRPr>
+            </a:pPr>
+            <a:r>
+              <a:rPr b="1" sz="1200">
+                <a:solidFill>
+                  <a:srgbClr val="0F172A"/>
+                </a:solidFill>
+              </a:rPr>
+              <a:t>• Binary Action Buttons: </a:t>
+            </a:r>
+            <a:r>
+              <a:rPr b="0" sz="1200">
+                <a:solidFill>
+                  <a:srgbClr val="475569"/>
+                </a:solidFill>
+              </a:rPr>
+              <a:t>Questions feature clean Yes and No action buttons for rapid entry.</a:t>
+            </a:r>
+          </a:p>
+        </p:txBody>
+      </p:sp>
+      <p:sp>
+        <p:nvSpPr>
+          <p:cNvPr id="6" name="Rounded Rectangle 5"/>
+          <p:cNvSpPr/>
+          <p:nvPr/>
+        </p:nvSpPr>
+        <p:spPr>
+          <a:xfrm>
+            <a:off x="6217920" y="1463040"/>
+            <a:ext cx="5212080" cy="4846320"/>
+          </a:xfrm>
+          <a:prstGeom prst="roundRect">
+            <a:avLst/>
+          </a:prstGeom>
+          <a:solidFill>
+            <a:srgbClr val="FFFFFF"/>
+          </a:solidFill>
+          <a:ln w="19050">
+            <a:solidFill>
+              <a:srgbClr val="E2E8F0"/>
+            </a:solidFill>
+          </a:ln>
+        </p:spPr>
+        <p:style>
+          <a:lnRef idx="1">
+            <a:schemeClr val="accent1"/>
+          </a:lnRef>
+          <a:fillRef idx="3">
+            <a:schemeClr val="accent1"/>
+          </a:fillRef>
+          <a:effectRef idx="2">
+            <a:schemeClr val="accent1"/>
+          </a:effectRef>
+          <a:fontRef idx="minor">
+            <a:schemeClr val="lt1"/>
+          </a:fontRef>
+        </p:style>
+        <p:txBody>
+          <a:bodyPr rtlCol="0" anchor="ctr"/>
+          <a:lstStyle/>
+          <a:p>
+            <a:pPr algn="ctr"/>
+          </a:p>
+        </p:txBody>
+      </p:sp>
+      <p:sp>
+        <p:nvSpPr>
+          <p:cNvPr id="7" name="TextBox 6"/>
+          <p:cNvSpPr txBox="1"/>
+          <p:nvPr/>
+        </p:nvSpPr>
+        <p:spPr>
+          <a:xfrm>
+            <a:off x="6400800" y="1645920"/>
+            <a:ext cx="4846320" cy="4480560"/>
+          </a:xfrm>
+          <a:prstGeom prst="rect">
+            <a:avLst/>
+          </a:prstGeom>
+          <a:noFill/>
+        </p:spPr>
+        <p:txBody>
+          <a:bodyPr wrap="square">
+            <a:spAutoFit/>
+          </a:bodyPr>
+          <a:lstStyle/>
+          <a:p>
+            <a:pPr>
+              <a:spcAft>
+                <a:spcPts val="1000"/>
+              </a:spcAft>
+              <a:defRPr sz="1600" b="1">
+                <a:solidFill>
+                  <a:srgbClr val="10B981"/>
+                </a:solidFill>
+                <a:latin typeface="Arial"/>
+              </a:defRPr>
+            </a:pPr>
+            <a:r>
+              <a:t>Controlled Pagination UX</a:t>
+            </a:r>
+          </a:p>
+          <a:p>
+            <a:pPr>
+              <a:spcAft>
+                <a:spcPts val="600"/>
+              </a:spcAft>
+              <a:defRPr>
+                <a:latin typeface="Arial"/>
+              </a:defRPr>
+            </a:pPr>
+            <a:r>
+              <a:rPr b="1" sz="1200">
+                <a:solidFill>
+                  <a:srgbClr val="0F172A"/>
+                </a:solidFill>
+              </a:rPr>
+              <a:t>• 5-Item Maximum Pagination: </a:t>
+            </a:r>
+            <a:r>
+              <a:rPr b="0" sz="1200">
+                <a:solidFill>
+                  <a:srgbClr val="475569"/>
+                </a:solidFill>
+              </a:rPr>
+              <a:t>Displays at most 5 questions per page when total questions exceed 5.</a:t>
+            </a:r>
+          </a:p>
+          <a:p>
+            <a:pPr>
+              <a:spcAft>
+                <a:spcPts val="600"/>
+              </a:spcAft>
+              <a:defRPr>
+                <a:latin typeface="Arial"/>
+              </a:defRPr>
+            </a:pPr>
+            <a:r>
+              <a:rPr b="1" sz="1200">
+                <a:solidFill>
+                  <a:srgbClr val="0F172A"/>
+                </a:solidFill>
+              </a:rPr>
+              <a:t>• Auto Control Hiding: </a:t>
+            </a:r>
+            <a:r>
+              <a:rPr b="0" sz="1200">
+                <a:solidFill>
+                  <a:srgbClr val="475569"/>
+                </a:solidFill>
+              </a:rPr>
+              <a:t>Hides previous/next buttons automatically when total questions &lt;= 5.</a:t>
+            </a:r>
+          </a:p>
+          <a:p>
+            <a:pPr>
+              <a:spcAft>
+                <a:spcPts val="600"/>
+              </a:spcAft>
+              <a:defRPr>
+                <a:latin typeface="Arial"/>
+              </a:defRPr>
+            </a:pPr>
+            <a:r>
+              <a:rPr b="1" sz="1200">
+                <a:solidFill>
+                  <a:srgbClr val="0F172A"/>
+                </a:solidFill>
+              </a:rPr>
+              <a:t>• Progress Indicator: </a:t>
+            </a:r>
+            <a:r>
+              <a:rPr b="0" sz="1200">
+                <a:solidFill>
+                  <a:srgbClr val="475569"/>
+                </a:solidFill>
+              </a:rPr>
+              <a:t>Displays active completion percentage and step counter.</a:t>
+            </a:r>
+          </a:p>
+          <a:p>
+            <a:pPr>
+              <a:spcAft>
+                <a:spcPts val="600"/>
+              </a:spcAft>
+              <a:defRPr>
+                <a:latin typeface="Arial"/>
+              </a:defRPr>
+            </a:pPr>
+            <a:r>
+              <a:rPr b="1" sz="1200">
+                <a:solidFill>
+                  <a:srgbClr val="0F172A"/>
+                </a:solidFill>
+              </a:rPr>
+              <a:t>• Inference Unlock: </a:t>
+            </a:r>
+            <a:r>
+              <a:rPr b="0" sz="1200">
+                <a:solidFill>
+                  <a:srgbClr val="475569"/>
+                </a:solidFill>
+              </a:rPr>
+              <a:t>Unlocks final diagnosis panel after question completion.</a:t>
+            </a:r>
+          </a:p>
+        </p:txBody>
+      </p:sp>
+    </p:spTree>
+  </p:cSld>
+  <p:clrMapOvr>
+    <a:masterClrMapping/>
+  </p:clrMapOvr>
+</p:sld>
+</file>
+
+<file path=ppt/slides/slide8.xml><?xml version="1.0" encoding="utf-8"?>
+<p:sld xmlns:a="http://schemas.openxmlformats.org/drawingml/2006/main" xmlns:p="http://schemas.openxmlformats.org/presentationml/2006/main" xmlns:r="http://schemas.openxmlformats.org/officeDocument/2006/relationships">
+  <p:cSld>
+    <p:bg>
+      <p:bgPr>
+        <a:solidFill>
+          <a:srgbClr val="F8FAFC"/>
+        </a:solidFill>
+        <a:effectLst/>
+      </p:bgPr>
+    </p:bg>
+    <p:spTree>
+      <p:nvGrpSpPr>
+        <p:cNvPr id="1" name=""/>
+        <p:cNvGrpSpPr/>
+        <p:nvPr/>
+      </p:nvGrpSpPr>
+      <p:grpSpPr/>
+      <p:sp>
+        <p:nvSpPr>
+          <p:cNvPr id="2" name="TextBox 1"/>
+          <p:cNvSpPr txBox="1"/>
+          <p:nvPr/>
+        </p:nvSpPr>
+        <p:spPr>
+          <a:xfrm>
+            <a:off x="731520" y="365760"/>
+            <a:ext cx="10698480" cy="365760"/>
+          </a:xfrm>
+          <a:prstGeom prst="rect">
+            <a:avLst/>
+          </a:prstGeom>
+          <a:noFill/>
+        </p:spPr>
+        <p:txBody>
+          <a:bodyPr wrap="none">
+            <a:spAutoFit/>
+          </a:bodyPr>
+          <a:lstStyle/>
+          <a:p>
+            <a:pPr>
+              <a:defRPr sz="1000" b="1">
+                <a:solidFill>
+                  <a:srgbClr val="0EA5E9"/>
+                </a:solidFill>
+                <a:latin typeface="Arial"/>
+              </a:defRPr>
+            </a:pPr>
+            <a:r>
+              <a:t>MEDICAL DIAGNOSIS EXPERT SYSTEM</a:t>
+            </a:r>
+          </a:p>
+        </p:txBody>
+      </p:sp>
+      <p:sp>
+        <p:nvSpPr>
+          <p:cNvPr id="3" name="TextBox 2"/>
+          <p:cNvSpPr txBox="1"/>
+          <p:nvPr/>
+        </p:nvSpPr>
+        <p:spPr>
+          <a:xfrm>
+            <a:off x="731520" y="685800"/>
+            <a:ext cx="10698480" cy="640080"/>
+          </a:xfrm>
+          <a:prstGeom prst="rect">
+            <a:avLst/>
+          </a:prstGeom>
+          <a:noFill/>
+        </p:spPr>
+        <p:txBody>
+          <a:bodyPr wrap="none">
+            <a:spAutoFit/>
+          </a:bodyPr>
+          <a:lstStyle/>
+          <a:p>
+            <a:pPr>
+              <a:defRPr sz="2400" b="1">
+                <a:solidFill>
+                  <a:srgbClr val="0F172A"/>
+                </a:solidFill>
+                <a:latin typeface="Arial"/>
+              </a:defRPr>
+            </a:pPr>
+            <a:r>
+              <a:t>Phase 3: Differential Output &amp; Confirmation Testing</a:t>
+            </a:r>
+          </a:p>
+        </p:txBody>
+      </p:sp>
+      <p:sp>
+        <p:nvSpPr>
+          <p:cNvPr id="4" name="Rounded Rectangle 3"/>
+          <p:cNvSpPr/>
+          <p:nvPr/>
+        </p:nvSpPr>
+        <p:spPr>
+          <a:xfrm>
+            <a:off x="731520" y="1463040"/>
+            <a:ext cx="5120640" cy="4846320"/>
+          </a:xfrm>
+          <a:prstGeom prst="roundRect">
+            <a:avLst/>
+          </a:prstGeom>
+          <a:solidFill>
+            <a:srgbClr val="FFFFFF"/>
+          </a:solidFill>
+          <a:ln w="19050">
+            <a:solidFill>
+              <a:srgbClr val="E2E8F0"/>
+            </a:solidFill>
+          </a:ln>
+        </p:spPr>
+        <p:style>
+          <a:lnRef idx="1">
+            <a:schemeClr val="accent1"/>
+          </a:lnRef>
+          <a:fillRef idx="3">
+            <a:schemeClr val="accent1"/>
+          </a:fillRef>
+          <a:effectRef idx="2">
+            <a:schemeClr val="accent1"/>
+          </a:effectRef>
+          <a:fontRef idx="minor">
+            <a:schemeClr val="lt1"/>
+          </a:fontRef>
+        </p:style>
+        <p:txBody>
+          <a:bodyPr rtlCol="0" anchor="ctr"/>
+          <a:lstStyle/>
+          <a:p>
+            <a:pPr algn="ctr"/>
+          </a:p>
+        </p:txBody>
+      </p:sp>
+      <p:sp>
+        <p:nvSpPr>
+          <p:cNvPr id="5" name="TextBox 4"/>
+          <p:cNvSpPr txBox="1"/>
+          <p:nvPr/>
+        </p:nvSpPr>
+        <p:spPr>
+          <a:xfrm>
+            <a:off x="914400" y="1645920"/>
+            <a:ext cx="4754880" cy="4480560"/>
+          </a:xfrm>
+          <a:prstGeom prst="rect">
+            <a:avLst/>
+          </a:prstGeom>
+          <a:noFill/>
+        </p:spPr>
+        <p:txBody>
+          <a:bodyPr wrap="square">
+            <a:spAutoFit/>
+          </a:bodyPr>
+          <a:lstStyle/>
+          <a:p>
+            <a:pPr>
+              <a:spcAft>
+                <a:spcPts val="1000"/>
+              </a:spcAft>
+              <a:defRPr sz="1600" b="1">
+                <a:solidFill>
+                  <a:srgbClr val="0EA5E9"/>
+                </a:solidFill>
+                <a:latin typeface="Arial"/>
+              </a:defRPr>
+            </a:pPr>
+            <a:r>
+              <a:t>Differential Diagnosis Output</a:t>
+            </a:r>
+          </a:p>
+          <a:p>
+            <a:pPr>
+              <a:spcAft>
+                <a:spcPts val="600"/>
+              </a:spcAft>
+              <a:defRPr>
+                <a:latin typeface="Arial"/>
+              </a:defRPr>
+            </a:pPr>
+            <a:r>
+              <a:rPr b="1" sz="1200">
+                <a:solidFill>
+                  <a:srgbClr val="0F172A"/>
+                </a:solidFill>
+              </a:rPr>
+              <a:t>• Primary Diagnosis Card: </a:t>
+            </a:r>
+            <a:r>
+              <a:rPr b="0" sz="1200">
+                <a:solidFill>
+                  <a:srgbClr val="475569"/>
+                </a:solidFill>
+              </a:rPr>
+              <a:t>Displays leading disease, category, ICD-10 code, and description.</a:t>
+            </a:r>
+          </a:p>
+          <a:p>
+            <a:pPr>
+              <a:spcAft>
+                <a:spcPts val="600"/>
+              </a:spcAft>
+              <a:defRPr>
+                <a:latin typeface="Arial"/>
+              </a:defRPr>
+            </a:pPr>
+            <a:r>
+              <a:rPr b="1" sz="1200">
+                <a:solidFill>
+                  <a:srgbClr val="0F172A"/>
+                </a:solidFill>
+              </a:rPr>
+              <a:t>• Confidence Score: </a:t>
+            </a:r>
+            <a:r>
+              <a:rPr b="0" sz="1200">
+                <a:solidFill>
+                  <a:srgbClr val="475569"/>
+                </a:solidFill>
+              </a:rPr>
+              <a:t>Renders calculated confidence percentage based on matched rules.</a:t>
+            </a:r>
+          </a:p>
+          <a:p>
+            <a:pPr>
+              <a:spcAft>
+                <a:spcPts val="600"/>
+              </a:spcAft>
+              <a:defRPr>
+                <a:latin typeface="Arial"/>
+              </a:defRPr>
+            </a:pPr>
+            <a:r>
+              <a:rPr b="1" sz="1200">
+                <a:solidFill>
+                  <a:srgbClr val="0F172A"/>
+                </a:solidFill>
+              </a:rPr>
+              <a:t>• Recommended Tests: </a:t>
+            </a:r>
+            <a:r>
+              <a:rPr b="0" sz="1200">
+                <a:solidFill>
+                  <a:srgbClr val="475569"/>
+                </a:solidFill>
+              </a:rPr>
+              <a:t>Specifies laboratory test name, sample type, and urgency level.</a:t>
+            </a:r>
+          </a:p>
+          <a:p>
+            <a:pPr>
+              <a:spcAft>
+                <a:spcPts val="600"/>
+              </a:spcAft>
+              <a:defRPr>
+                <a:latin typeface="Arial"/>
+              </a:defRPr>
+            </a:pPr>
+            <a:r>
+              <a:rPr b="1" sz="1200">
+                <a:solidFill>
+                  <a:srgbClr val="0F172A"/>
+                </a:solidFill>
+              </a:rPr>
+              <a:t>• Eliminated Candidate Pool: </a:t>
+            </a:r>
+            <a:r>
+              <a:rPr b="0" sz="1200">
+                <a:solidFill>
+                  <a:srgbClr val="475569"/>
+                </a:solidFill>
+              </a:rPr>
+              <a:t>Lists ruled-out diseases with explicit elimination reasons.</a:t>
+            </a:r>
+          </a:p>
+        </p:txBody>
+      </p:sp>
+      <p:sp>
+        <p:nvSpPr>
+          <p:cNvPr id="6" name="Rounded Rectangle 5"/>
+          <p:cNvSpPr/>
+          <p:nvPr/>
+        </p:nvSpPr>
+        <p:spPr>
+          <a:xfrm>
+            <a:off x="6217920" y="1463040"/>
+            <a:ext cx="5212080" cy="4846320"/>
+          </a:xfrm>
+          <a:prstGeom prst="roundRect">
+            <a:avLst/>
+          </a:prstGeom>
+          <a:solidFill>
+            <a:srgbClr val="FFFFFF"/>
+          </a:solidFill>
+          <a:ln w="19050">
+            <a:solidFill>
+              <a:srgbClr val="E2E8F0"/>
+            </a:solidFill>
+          </a:ln>
+        </p:spPr>
+        <p:style>
+          <a:lnRef idx="1">
+            <a:schemeClr val="accent1"/>
+          </a:lnRef>
+          <a:fillRef idx="3">
+            <a:schemeClr val="accent1"/>
+          </a:fillRef>
+          <a:effectRef idx="2">
+            <a:schemeClr val="accent1"/>
+          </a:effectRef>
+          <a:fontRef idx="minor">
+            <a:schemeClr val="lt1"/>
+          </a:fontRef>
+        </p:style>
+        <p:txBody>
+          <a:bodyPr rtlCol="0" anchor="ctr"/>
+          <a:lstStyle/>
+          <a:p>
+            <a:pPr algn="ctr"/>
+          </a:p>
+        </p:txBody>
+      </p:sp>
+      <p:sp>
+        <p:nvSpPr>
+          <p:cNvPr id="7" name="TextBox 6"/>
+          <p:cNvSpPr txBox="1"/>
+          <p:nvPr/>
+        </p:nvSpPr>
+        <p:spPr>
+          <a:xfrm>
+            <a:off x="6400800" y="1645920"/>
+            <a:ext cx="4846320" cy="4480560"/>
+          </a:xfrm>
+          <a:prstGeom prst="rect">
+            <a:avLst/>
+          </a:prstGeom>
+          <a:noFill/>
+        </p:spPr>
+        <p:txBody>
+          <a:bodyPr wrap="square">
+            <a:spAutoFit/>
+          </a:bodyPr>
+          <a:lstStyle/>
+          <a:p>
+            <a:pPr>
+              <a:spcAft>
+                <a:spcPts val="1000"/>
+              </a:spcAft>
+              <a:defRPr sz="1600" b="1">
+                <a:solidFill>
+                  <a:srgbClr val="10B981"/>
+                </a:solidFill>
+                <a:latin typeface="Arial"/>
+              </a:defRPr>
+            </a:pPr>
+            <a:r>
+              <a:t>Lab Confirmation Processing</a:t>
+            </a:r>
+          </a:p>
+          <a:p>
+            <a:pPr>
+              <a:spcAft>
+                <a:spcPts val="600"/>
+              </a:spcAft>
+              <a:defRPr>
+                <a:latin typeface="Arial"/>
+              </a:defRPr>
+            </a:pPr>
+            <a:r>
+              <a:rPr b="1" sz="1200">
+                <a:solidFill>
+                  <a:srgbClr val="0F172A"/>
+                </a:solidFill>
+              </a:rPr>
+              <a:t>• Test Positive Outcome: </a:t>
+            </a:r>
+            <a:r>
+              <a:rPr b="0" sz="1200">
+                <a:solidFill>
+                  <a:srgbClr val="475569"/>
+                </a:solidFill>
+              </a:rPr>
+              <a:t>Locks confirmed diagnosis, displays prescribed medications, and halts testing.</a:t>
+            </a:r>
+          </a:p>
+          <a:p>
+            <a:pPr>
+              <a:spcAft>
+                <a:spcPts val="600"/>
+              </a:spcAft>
+              <a:defRPr>
+                <a:latin typeface="Arial"/>
+              </a:defRPr>
+            </a:pPr>
+            <a:r>
+              <a:rPr b="1" sz="1200">
+                <a:solidFill>
+                  <a:srgbClr val="0F172A"/>
+                </a:solidFill>
+              </a:rPr>
+              <a:t>• Test Negative Outcome: </a:t>
+            </a:r>
+            <a:r>
+              <a:rPr b="0" sz="1200">
+                <a:solidFill>
+                  <a:srgbClr val="475569"/>
+                </a:solidFill>
+              </a:rPr>
+              <a:t>Eliminates tested condition, displays next candidate, and updates differential pool.</a:t>
+            </a:r>
+          </a:p>
+          <a:p>
+            <a:pPr>
+              <a:spcAft>
+                <a:spcPts val="600"/>
+              </a:spcAft>
+              <a:defRPr>
+                <a:latin typeface="Arial"/>
+              </a:defRPr>
+            </a:pPr>
+            <a:r>
+              <a:rPr b="1" sz="1200">
+                <a:solidFill>
+                  <a:srgbClr val="0F172A"/>
+                </a:solidFill>
+              </a:rPr>
+              <a:t>• Ruled-Out Notice: </a:t>
+            </a:r>
+            <a:r>
+              <a:rPr b="0" sz="1200">
+                <a:solidFill>
+                  <a:srgbClr val="475569"/>
+                </a:solidFill>
+              </a:rPr>
+              <a:t>If all candidates test negative, displays a notice recommending broad-spectrum lab testing.</a:t>
+            </a:r>
+          </a:p>
+        </p:txBody>
+      </p:sp>
+    </p:spTree>
+  </p:cSld>
+  <p:clrMapOvr>
+    <a:masterClrMapping/>
+  </p:clrMapOvr>
+</p:sld>
+</file>
+
+<file path=ppt/slides/slide9.xml><?xml version="1.0" encoding="utf-8"?>
+<p:sld xmlns:a="http://schemas.openxmlformats.org/drawingml/2006/main" xmlns:p="http://schemas.openxmlformats.org/presentationml/2006/main" xmlns:r="http://schemas.openxmlformats.org/officeDocument/2006/relationships">
+  <p:cSld>
+    <p:bg>
+      <p:bgPr>
+        <a:solidFill>
+          <a:srgbClr val="F8FAFC"/>
+        </a:solidFill>
+        <a:effectLst/>
+      </p:bgPr>
+    </p:bg>
+    <p:spTree>
+      <p:nvGrpSpPr>
+        <p:cNvPr id="1" name=""/>
+        <p:cNvGrpSpPr/>
+        <p:nvPr/>
+      </p:nvGrpSpPr>
+      <p:grpSpPr/>
+      <p:sp>
+        <p:nvSpPr>
+          <p:cNvPr id="2" name="TextBox 1"/>
+          <p:cNvSpPr txBox="1"/>
+          <p:nvPr/>
+        </p:nvSpPr>
+        <p:spPr>
+          <a:xfrm>
+            <a:off x="731520" y="365760"/>
+            <a:ext cx="10698480" cy="365760"/>
+          </a:xfrm>
+          <a:prstGeom prst="rect">
+            <a:avLst/>
+          </a:prstGeom>
+          <a:noFill/>
+        </p:spPr>
+        <p:txBody>
+          <a:bodyPr wrap="none">
+            <a:spAutoFit/>
+          </a:bodyPr>
+          <a:lstStyle/>
+          <a:p>
+            <a:pPr>
+              <a:defRPr sz="1000" b="1">
+                <a:solidFill>
+                  <a:srgbClr val="0EA5E9"/>
+                </a:solidFill>
+                <a:latin typeface="Arial"/>
+              </a:defRPr>
+            </a:pPr>
+            <a:r>
+              <a:t>MEDICAL DIAGNOSIS EXPERT SYSTEM</a:t>
+            </a:r>
+          </a:p>
+        </p:txBody>
+      </p:sp>
+      <p:sp>
+        <p:nvSpPr>
+          <p:cNvPr id="3" name="TextBox 2"/>
+          <p:cNvSpPr txBox="1"/>
+          <p:nvPr/>
+        </p:nvSpPr>
+        <p:spPr>
+          <a:xfrm>
+            <a:off x="731520" y="685800"/>
+            <a:ext cx="10698480" cy="640080"/>
+          </a:xfrm>
+          <a:prstGeom prst="rect">
+            <a:avLst/>
+          </a:prstGeom>
+          <a:noFill/>
+        </p:spPr>
+        <p:txBody>
+          <a:bodyPr wrap="none">
+            <a:spAutoFit/>
+          </a:bodyPr>
+          <a:lstStyle/>
+          <a:p>
+            <a:pPr>
+              <a:defRPr sz="2400" b="1">
+                <a:solidFill>
+                  <a:srgbClr val="0F172A"/>
+                </a:solidFill>
+                <a:latin typeface="Arial"/>
+              </a:defRPr>
+            </a:pPr>
+            <a:r>
+              <a:t>Step-by-Step Clinical Triage Workflow</a:t>
+            </a:r>
+          </a:p>
+        </p:txBody>
+      </p:sp>
+      <p:sp>
+        <p:nvSpPr>
+          <p:cNvPr id="4" name="Rounded Rectangle 3"/>
+          <p:cNvSpPr/>
+          <p:nvPr/>
+        </p:nvSpPr>
+        <p:spPr>
+          <a:xfrm>
+            <a:off x="731520" y="1463040"/>
+            <a:ext cx="2468880" cy="4846320"/>
+          </a:xfrm>
+          <a:prstGeom prst="roundRect">
+            <a:avLst/>
+          </a:prstGeom>
+          <a:solidFill>
+            <a:srgbClr val="FFFFFF"/>
+          </a:solidFill>
+          <a:ln w="19050">
+            <a:solidFill>
+              <a:srgbClr val="E2E8F0"/>
+            </a:solidFill>
+          </a:ln>
+        </p:spPr>
+        <p:style>
+          <a:lnRef idx="1">
+            <a:schemeClr val="accent1"/>
+          </a:lnRef>
+          <a:fillRef idx="3">
+            <a:schemeClr val="accent1"/>
+          </a:fillRef>
+          <a:effectRef idx="2">
+            <a:schemeClr val="accent1"/>
+          </a:effectRef>
+          <a:fontRef idx="minor">
+            <a:schemeClr val="lt1"/>
+          </a:fontRef>
+        </p:style>
+        <p:txBody>
+          <a:bodyPr rtlCol="0" anchor="ctr"/>
+          <a:lstStyle/>
+          <a:p>
+            <a:pPr algn="ctr"/>
+          </a:p>
+        </p:txBody>
+      </p:sp>
+      <p:sp>
+        <p:nvSpPr>
+          <p:cNvPr id="5" name="TextBox 4"/>
+          <p:cNvSpPr txBox="1"/>
+          <p:nvPr/>
+        </p:nvSpPr>
+        <p:spPr>
+          <a:xfrm>
+            <a:off x="914400" y="1645920"/>
+            <a:ext cx="2103120" cy="4480560"/>
+          </a:xfrm>
+          <a:prstGeom prst="rect">
+            <a:avLst/>
+          </a:prstGeom>
+          <a:noFill/>
+        </p:spPr>
+        <p:txBody>
+          <a:bodyPr wrap="square">
+            <a:spAutoFit/>
+          </a:bodyPr>
+          <a:lstStyle/>
+          <a:p>
+            <a:pPr>
+              <a:spcAft>
+                <a:spcPts val="1000"/>
+              </a:spcAft>
+              <a:defRPr sz="1600" b="1">
+                <a:solidFill>
+                  <a:srgbClr val="6366F1"/>
+                </a:solidFill>
+                <a:latin typeface="Arial"/>
+              </a:defRPr>
+            </a:pPr>
+            <a:r>
+              <a:t>Step 1: Auth</a:t>
+            </a:r>
+          </a:p>
+          <a:p>
+            <a:pPr>
+              <a:spcAft>
+                <a:spcPts val="600"/>
+              </a:spcAft>
+              <a:defRPr>
+                <a:latin typeface="Arial"/>
+              </a:defRPr>
+            </a:pPr>
+            <a:r>
+              <a:rPr b="1" sz="1200">
+                <a:solidFill>
+                  <a:srgbClr val="0F172A"/>
+                </a:solidFill>
+              </a:rPr>
+              <a:t>• Sign In Portal: </a:t>
+            </a:r>
+            <a:r>
+              <a:rPr b="0" sz="1200">
+                <a:solidFill>
+                  <a:srgbClr val="475569"/>
+                </a:solidFill>
+              </a:rPr>
+              <a:t>Clinician logs in or registers profile.</a:t>
+            </a:r>
+          </a:p>
+          <a:p>
+            <a:pPr>
+              <a:spcAft>
+                <a:spcPts val="600"/>
+              </a:spcAft>
+              <a:defRPr>
+                <a:latin typeface="Arial"/>
+              </a:defRPr>
+            </a:pPr>
+            <a:r>
+              <a:rPr b="1" sz="1200">
+                <a:solidFill>
+                  <a:srgbClr val="0F172A"/>
+                </a:solidFill>
+              </a:rPr>
+              <a:t>• Profile Active: </a:t>
+            </a:r>
+            <a:r>
+              <a:rPr b="0" sz="1200">
+                <a:solidFill>
+                  <a:srgbClr val="475569"/>
+                </a:solidFill>
+              </a:rPr>
+              <a:t>Workspace launches with active details.</a:t>
+            </a:r>
+          </a:p>
+        </p:txBody>
+      </p:sp>
+      <p:sp>
+        <p:nvSpPr>
+          <p:cNvPr id="6" name="Rounded Rectangle 5"/>
+          <p:cNvSpPr/>
+          <p:nvPr/>
+        </p:nvSpPr>
+        <p:spPr>
+          <a:xfrm>
+            <a:off x="3474720" y="1463040"/>
+            <a:ext cx="2468880" cy="4846320"/>
+          </a:xfrm>
+          <a:prstGeom prst="roundRect">
+            <a:avLst/>
+          </a:prstGeom>
+          <a:solidFill>
+            <a:srgbClr val="FFFFFF"/>
+          </a:solidFill>
+          <a:ln w="19050">
+            <a:solidFill>
+              <a:srgbClr val="E2E8F0"/>
+            </a:solidFill>
+          </a:ln>
+        </p:spPr>
+        <p:style>
+          <a:lnRef idx="1">
+            <a:schemeClr val="accent1"/>
+          </a:lnRef>
+          <a:fillRef idx="3">
+            <a:schemeClr val="accent1"/>
+          </a:fillRef>
+          <a:effectRef idx="2">
+            <a:schemeClr val="accent1"/>
+          </a:effectRef>
+          <a:fontRef idx="minor">
+            <a:schemeClr val="lt1"/>
+          </a:fontRef>
+        </p:style>
+        <p:txBody>
+          <a:bodyPr rtlCol="0" anchor="ctr"/>
+          <a:lstStyle/>
+          <a:p>
+            <a:pPr algn="ctr"/>
+          </a:p>
+        </p:txBody>
+      </p:sp>
+      <p:sp>
+        <p:nvSpPr>
+          <p:cNvPr id="7" name="TextBox 6"/>
+          <p:cNvSpPr txBox="1"/>
+          <p:nvPr/>
+        </p:nvSpPr>
+        <p:spPr>
+          <a:xfrm>
+            <a:off x="3657600" y="1645920"/>
+            <a:ext cx="2103120" cy="4480560"/>
+          </a:xfrm>
+          <a:prstGeom prst="rect">
+            <a:avLst/>
+          </a:prstGeom>
+          <a:noFill/>
+        </p:spPr>
+        <p:txBody>
+          <a:bodyPr wrap="square">
+            <a:spAutoFit/>
+          </a:bodyPr>
+          <a:lstStyle/>
+          <a:p>
+            <a:pPr>
+              <a:spcAft>
+                <a:spcPts val="1000"/>
+              </a:spcAft>
+              <a:defRPr sz="1600" b="1">
+                <a:solidFill>
+                  <a:srgbClr val="0EA5E9"/>
+                </a:solidFill>
+                <a:latin typeface="Arial"/>
+              </a:defRPr>
+            </a:pPr>
+            <a:r>
+              <a:t>Step 2: Symptoms</a:t>
+            </a:r>
+          </a:p>
+          <a:p>
+            <a:pPr>
+              <a:spcAft>
+                <a:spcPts val="600"/>
+              </a:spcAft>
+              <a:defRPr>
+                <a:latin typeface="Arial"/>
+              </a:defRPr>
+            </a:pPr>
+            <a:r>
+              <a:rPr b="1" sz="1200">
+                <a:solidFill>
+                  <a:srgbClr val="0F172A"/>
+                </a:solidFill>
+              </a:rPr>
+              <a:t>• Intake Selection: </a:t>
+            </a:r>
+            <a:r>
+              <a:rPr b="0" sz="1200">
+                <a:solidFill>
+                  <a:srgbClr val="475569"/>
+                </a:solidFill>
+              </a:rPr>
+              <a:t>Select primary symptoms &amp; risk factors.</a:t>
+            </a:r>
+          </a:p>
+          <a:p>
+            <a:pPr>
+              <a:spcAft>
+                <a:spcPts val="600"/>
+              </a:spcAft>
+              <a:defRPr>
+                <a:latin typeface="Arial"/>
+              </a:defRPr>
+            </a:pPr>
+            <a:r>
+              <a:rPr b="1" sz="1200">
+                <a:solidFill>
+                  <a:srgbClr val="0F172A"/>
+                </a:solidFill>
+              </a:rPr>
+              <a:t>• Run Inference: </a:t>
+            </a:r>
+            <a:r>
+              <a:rPr b="0" sz="1200">
+                <a:solidFill>
+                  <a:srgbClr val="475569"/>
+                </a:solidFill>
+              </a:rPr>
+              <a:t>Execute relational logic engine.</a:t>
+            </a:r>
+          </a:p>
+        </p:txBody>
+      </p:sp>
+      <p:sp>
+        <p:nvSpPr>
+          <p:cNvPr id="8" name="Rounded Rectangle 7"/>
+          <p:cNvSpPr/>
+          <p:nvPr/>
+        </p:nvSpPr>
+        <p:spPr>
+          <a:xfrm>
+            <a:off x="6217920" y="1463040"/>
+            <a:ext cx="2468880" cy="4846320"/>
+          </a:xfrm>
+          <a:prstGeom prst="roundRect">
+            <a:avLst/>
+          </a:prstGeom>
+          <a:solidFill>
+            <a:srgbClr val="FFFFFF"/>
+          </a:solidFill>
+          <a:ln w="19050">
+            <a:solidFill>
+              <a:srgbClr val="E2E8F0"/>
+            </a:solidFill>
+          </a:ln>
+        </p:spPr>
+        <p:style>
+          <a:lnRef idx="1">
+            <a:schemeClr val="accent1"/>
+          </a:lnRef>
+          <a:fillRef idx="3">
+            <a:schemeClr val="accent1"/>
+          </a:fillRef>
+          <a:effectRef idx="2">
+            <a:schemeClr val="accent1"/>
+          </a:effectRef>
+          <a:fontRef idx="minor">
+            <a:schemeClr val="lt1"/>
+          </a:fontRef>
+        </p:style>
+        <p:txBody>
+          <a:bodyPr rtlCol="0" anchor="ctr"/>
+          <a:lstStyle/>
+          <a:p>
+            <a:pPr algn="ctr"/>
+          </a:p>
+        </p:txBody>
+      </p:sp>
+      <p:sp>
+        <p:nvSpPr>
+          <p:cNvPr id="9" name="TextBox 8"/>
+          <p:cNvSpPr txBox="1"/>
+          <p:nvPr/>
+        </p:nvSpPr>
+        <p:spPr>
+          <a:xfrm>
+            <a:off x="6400800" y="1645920"/>
+            <a:ext cx="2103120" cy="4480560"/>
+          </a:xfrm>
+          <a:prstGeom prst="rect">
+            <a:avLst/>
+          </a:prstGeom>
+          <a:noFill/>
+        </p:spPr>
+        <p:txBody>
+          <a:bodyPr wrap="square">
+            <a:spAutoFit/>
+          </a:bodyPr>
+          <a:lstStyle/>
+          <a:p>
+            <a:pPr>
+              <a:spcAft>
+                <a:spcPts val="1000"/>
+              </a:spcAft>
+              <a:defRPr sz="1600" b="1">
+                <a:solidFill>
+                  <a:srgbClr val="10B981"/>
+                </a:solidFill>
+                <a:latin typeface="Arial"/>
+              </a:defRPr>
+            </a:pPr>
+            <a:r>
+              <a:t>Step 3: Questions</a:t>
+            </a:r>
+          </a:p>
+          <a:p>
+            <a:pPr>
+              <a:spcAft>
+                <a:spcPts val="600"/>
+              </a:spcAft>
+              <a:defRPr>
+                <a:latin typeface="Arial"/>
+              </a:defRPr>
+            </a:pPr>
+            <a:r>
+              <a:rPr b="1" sz="1200">
+                <a:solidFill>
+                  <a:srgbClr val="0F172A"/>
+                </a:solidFill>
+              </a:rPr>
+              <a:t>• Top 3 Candidate Pool: </a:t>
+            </a:r>
+            <a:r>
+              <a:rPr b="0" sz="1200">
+                <a:solidFill>
+                  <a:srgbClr val="475569"/>
+                </a:solidFill>
+              </a:rPr>
+              <a:t>System locks top 3 candidate diseases.</a:t>
+            </a:r>
+          </a:p>
+          <a:p>
+            <a:pPr>
+              <a:spcAft>
+                <a:spcPts val="600"/>
+              </a:spcAft>
+              <a:defRPr>
+                <a:latin typeface="Arial"/>
+              </a:defRPr>
+            </a:pPr>
+            <a:r>
+              <a:rPr b="1" sz="1200">
+                <a:solidFill>
+                  <a:srgbClr val="0F172A"/>
+                </a:solidFill>
+              </a:rPr>
+              <a:t>• Sequential Survey: </a:t>
+            </a:r>
+            <a:r>
+              <a:rPr b="0" sz="1200">
+                <a:solidFill>
+                  <a:srgbClr val="475569"/>
+                </a:solidFill>
+              </a:rPr>
+              <a:t>Answer Yes/No follow-up questions.</a:t>
+            </a:r>
+          </a:p>
+        </p:txBody>
+      </p:sp>
+      <p:sp>
+        <p:nvSpPr>
+          <p:cNvPr id="10" name="Rounded Rectangle 9"/>
+          <p:cNvSpPr/>
+          <p:nvPr/>
+        </p:nvSpPr>
+        <p:spPr>
+          <a:xfrm>
+            <a:off x="8961120" y="1463040"/>
+            <a:ext cx="2468880" cy="4846320"/>
+          </a:xfrm>
+          <a:prstGeom prst="roundRect">
+            <a:avLst/>
+          </a:prstGeom>
+          <a:solidFill>
+            <a:srgbClr val="FFFFFF"/>
+          </a:solidFill>
+          <a:ln w="19050">
+            <a:solidFill>
+              <a:srgbClr val="E2E8F0"/>
+            </a:solidFill>
+          </a:ln>
+        </p:spPr>
+        <p:style>
+          <a:lnRef idx="1">
+            <a:schemeClr val="accent1"/>
+          </a:lnRef>
+          <a:fillRef idx="3">
+            <a:schemeClr val="accent1"/>
+          </a:fillRef>
+          <a:effectRef idx="2">
+            <a:schemeClr val="accent1"/>
+          </a:effectRef>
+          <a:fontRef idx="minor">
+            <a:schemeClr val="lt1"/>
+          </a:fontRef>
+        </p:style>
+        <p:txBody>
+          <a:bodyPr rtlCol="0" anchor="ctr"/>
+          <a:lstStyle/>
+          <a:p>
+            <a:pPr algn="ctr"/>
+          </a:p>
+        </p:txBody>
+      </p:sp>
+      <p:sp>
+        <p:nvSpPr>
+          <p:cNvPr id="11" name="TextBox 10"/>
+          <p:cNvSpPr txBox="1"/>
+          <p:nvPr/>
+        </p:nvSpPr>
+        <p:spPr>
+          <a:xfrm>
+            <a:off x="9144000" y="1645920"/>
+            <a:ext cx="2103120" cy="4480560"/>
+          </a:xfrm>
+          <a:prstGeom prst="rect">
+            <a:avLst/>
+          </a:prstGeom>
+          <a:noFill/>
+        </p:spPr>
+        <p:txBody>
+          <a:bodyPr wrap="square">
+            <a:spAutoFit/>
+          </a:bodyPr>
+          <a:lstStyle/>
+          <a:p>
+            <a:pPr>
+              <a:spcAft>
+                <a:spcPts val="1000"/>
+              </a:spcAft>
+              <a:defRPr sz="1600" b="1">
+                <a:solidFill>
+                  <a:srgbClr val="6366F1"/>
+                </a:solidFill>
+                <a:latin typeface="Arial"/>
+              </a:defRPr>
+            </a:pPr>
+            <a:r>
+              <a:t>Step 4: Confirm</a:t>
+            </a:r>
+          </a:p>
+          <a:p>
+            <a:pPr>
+              <a:spcAft>
+                <a:spcPts val="600"/>
+              </a:spcAft>
+              <a:defRPr>
+                <a:latin typeface="Arial"/>
+              </a:defRPr>
+            </a:pPr>
+            <a:r>
+              <a:rPr b="1" sz="1200">
+                <a:solidFill>
+                  <a:srgbClr val="0F172A"/>
+                </a:solidFill>
+              </a:rPr>
+              <a:t>• Review Differential: </a:t>
+            </a:r>
+            <a:r>
+              <a:rPr b="0" sz="1200">
+                <a:solidFill>
+                  <a:srgbClr val="475569"/>
+                </a:solidFill>
+              </a:rPr>
+              <a:t>Examine diagnosis &amp; lab recommendations.</a:t>
+            </a:r>
+          </a:p>
+          <a:p>
+            <a:pPr>
+              <a:spcAft>
+                <a:spcPts val="600"/>
+              </a:spcAft>
+              <a:defRPr>
+                <a:latin typeface="Arial"/>
+              </a:defRPr>
+            </a:pPr>
+            <a:r>
+              <a:rPr b="1" sz="1200">
+                <a:solidFill>
+                  <a:srgbClr val="0F172A"/>
+                </a:solidFill>
+              </a:rPr>
+              <a:t>• Record Test Result: </a:t>
+            </a:r>
+            <a:r>
+              <a:rPr b="0" sz="1200">
+                <a:solidFill>
+                  <a:srgbClr val="475569"/>
+                </a:solidFill>
+              </a:rPr>
+              <a:t>Submit Positive/Negative test outcome.</a:t>
             </a:r>
           </a:p>
         </p:txBody>

</xml_diff>